<commit_message>
vault backup: 2026-06-20 20:58:27
</commit_message>
<xml_diff>
--- a/ТПР/Метод_минимального_элемента.pptx
+++ b/ТПР/Метод_минимального_элемента.pptx
@@ -5,19 +5,19 @@
     <p:sldMasterId id="2147483648" r:id="rId1"/>
   </p:sldMasterIdLst>
   <p:sldIdLst>
-    <p:sldId id="256" r:id="rId7"/>
-    <p:sldId id="257" r:id="rId8"/>
-    <p:sldId id="258" r:id="rId9"/>
-    <p:sldId id="259" r:id="rId10"/>
-    <p:sldId id="260" r:id="rId11"/>
-    <p:sldId id="261" r:id="rId12"/>
-    <p:sldId id="262" r:id="rId13"/>
-    <p:sldId id="263" r:id="rId14"/>
-    <p:sldId id="264" r:id="rId15"/>
-    <p:sldId id="265" r:id="rId16"/>
-    <p:sldId id="266" r:id="rId17"/>
+    <p:sldId id="256" r:id="rId2"/>
+    <p:sldId id="257" r:id="rId3"/>
+    <p:sldId id="258" r:id="rId4"/>
+    <p:sldId id="259" r:id="rId5"/>
+    <p:sldId id="260" r:id="rId6"/>
+    <p:sldId id="261" r:id="rId7"/>
+    <p:sldId id="262" r:id="rId8"/>
+    <p:sldId id="263" r:id="rId9"/>
+    <p:sldId id="264" r:id="rId10"/>
+    <p:sldId id="265" r:id="rId11"/>
+    <p:sldId id="266" r:id="rId12"/>
   </p:sldIdLst>
-  <p:sldSz cx="12191695" cy="6858000" type="screen4x3"/>
+  <p:sldSz cx="12192000" cy="6858000"/>
   <p:notesSz cx="6858000" cy="9144000"/>
   <p:defaultTextStyle>
     <a:defPPr>
@@ -114,6 +114,22 @@
       </a:defRPr>
     </a:lvl9pPr>
   </p:defaultTextStyle>
+  <p:extLst>
+    <p:ext uri="{EFAFB233-063F-42B5-8137-9DF3F51BA10A}">
+      <p15:sldGuideLst xmlns:p15="http://schemas.microsoft.com/office/powerpoint/2012/main">
+        <p15:guide id="1" orient="horz" pos="2160">
+          <p15:clr>
+            <a:srgbClr val="A4A3A4"/>
+          </p15:clr>
+        </p15:guide>
+        <p15:guide id="2" pos="2880">
+          <p15:clr>
+            <a:srgbClr val="A4A3A4"/>
+          </p15:clr>
+        </p15:guide>
+      </p15:sldGuideLst>
+    </p:ext>
+  </p:extLst>
 </p:presentation>
 </file>
 
@@ -155,10 +171,9 @@
           <a:lstStyle/>
           <a:p>
             <a:r>
-              <a:rPr lang="en-US" smtClean="0"/>
+              <a:rPr lang="en-US"/>
               <a:t>Click to edit Master title style</a:t>
             </a:r>
-            <a:endParaRPr lang="en-US"/>
           </a:p>
         </p:txBody>
       </p:sp>
@@ -274,10 +289,9 @@
           </a:lstStyle>
           <a:p>
             <a:r>
-              <a:rPr lang="en-US" smtClean="0"/>
+              <a:rPr lang="en-US"/>
               <a:t>Click to edit Master subtitle style</a:t>
             </a:r>
-            <a:endParaRPr lang="en-US"/>
           </a:p>
         </p:txBody>
       </p:sp>
@@ -298,7 +312,7 @@
           <a:p>
             <a:fld id="{5BCAD085-E8A6-8845-BD4E-CB4CCA059FC4}" type="datetimeFigureOut">
               <a:rPr lang="en-US" smtClean="0"/>
-              <a:t>1/27/13</a:t>
+              <a:t>6/20/2026</a:t>
             </a:fld>
             <a:endParaRPr lang="en-US"/>
           </a:p>
@@ -392,10 +406,9 @@
           <a:lstStyle/>
           <a:p>
             <a:r>
-              <a:rPr lang="en-US" smtClean="0"/>
+              <a:rPr lang="en-US"/>
               <a:t>Click to edit Master title style</a:t>
             </a:r>
-            <a:endParaRPr lang="en-US"/>
           </a:p>
         </p:txBody>
       </p:sp>
@@ -416,38 +429,37 @@
           <a:p>
             <a:pPr lvl="0"/>
             <a:r>
-              <a:rPr lang="en-US" smtClean="0"/>
+              <a:rPr lang="en-US"/>
               <a:t>Click to edit Master text styles</a:t>
             </a:r>
           </a:p>
           <a:p>
             <a:pPr lvl="1"/>
             <a:r>
-              <a:rPr lang="en-US" smtClean="0"/>
+              <a:rPr lang="en-US"/>
               <a:t>Second level</a:t>
             </a:r>
           </a:p>
           <a:p>
             <a:pPr lvl="2"/>
             <a:r>
-              <a:rPr lang="en-US" smtClean="0"/>
+              <a:rPr lang="en-US"/>
               <a:t>Third level</a:t>
             </a:r>
           </a:p>
           <a:p>
             <a:pPr lvl="3"/>
             <a:r>
-              <a:rPr lang="en-US" smtClean="0"/>
+              <a:rPr lang="en-US"/>
               <a:t>Fourth level</a:t>
             </a:r>
           </a:p>
           <a:p>
             <a:pPr lvl="4"/>
             <a:r>
-              <a:rPr lang="en-US" smtClean="0"/>
+              <a:rPr lang="en-US"/>
               <a:t>Fifth level</a:t>
             </a:r>
-            <a:endParaRPr lang="en-US"/>
           </a:p>
         </p:txBody>
       </p:sp>
@@ -468,7 +480,7 @@
           <a:p>
             <a:fld id="{5BCAD085-E8A6-8845-BD4E-CB4CCA059FC4}" type="datetimeFigureOut">
               <a:rPr lang="en-US" smtClean="0"/>
-              <a:t>1/27/13</a:t>
+              <a:t>6/20/2026</a:t>
             </a:fld>
             <a:endParaRPr lang="en-US"/>
           </a:p>
@@ -567,10 +579,9 @@
           <a:lstStyle/>
           <a:p>
             <a:r>
-              <a:rPr lang="en-US" smtClean="0"/>
+              <a:rPr lang="en-US"/>
               <a:t>Click to edit Master title style</a:t>
             </a:r>
-            <a:endParaRPr lang="en-US"/>
           </a:p>
         </p:txBody>
       </p:sp>
@@ -596,38 +607,37 @@
           <a:p>
             <a:pPr lvl="0"/>
             <a:r>
-              <a:rPr lang="en-US" smtClean="0"/>
+              <a:rPr lang="en-US"/>
               <a:t>Click to edit Master text styles</a:t>
             </a:r>
           </a:p>
           <a:p>
             <a:pPr lvl="1"/>
             <a:r>
-              <a:rPr lang="en-US" smtClean="0"/>
+              <a:rPr lang="en-US"/>
               <a:t>Second level</a:t>
             </a:r>
           </a:p>
           <a:p>
             <a:pPr lvl="2"/>
             <a:r>
-              <a:rPr lang="en-US" smtClean="0"/>
+              <a:rPr lang="en-US"/>
               <a:t>Third level</a:t>
             </a:r>
           </a:p>
           <a:p>
             <a:pPr lvl="3"/>
             <a:r>
-              <a:rPr lang="en-US" smtClean="0"/>
+              <a:rPr lang="en-US"/>
               <a:t>Fourth level</a:t>
             </a:r>
           </a:p>
           <a:p>
             <a:pPr lvl="4"/>
             <a:r>
-              <a:rPr lang="en-US" smtClean="0"/>
+              <a:rPr lang="en-US"/>
               <a:t>Fifth level</a:t>
             </a:r>
-            <a:endParaRPr lang="en-US"/>
           </a:p>
         </p:txBody>
       </p:sp>
@@ -648,7 +658,7 @@
           <a:p>
             <a:fld id="{5BCAD085-E8A6-8845-BD4E-CB4CCA059FC4}" type="datetimeFigureOut">
               <a:rPr lang="en-US" smtClean="0"/>
-              <a:t>1/27/13</a:t>
+              <a:t>6/20/2026</a:t>
             </a:fld>
             <a:endParaRPr lang="en-US"/>
           </a:p>
@@ -742,10 +752,9 @@
           <a:lstStyle/>
           <a:p>
             <a:r>
-              <a:rPr lang="en-US" smtClean="0"/>
+              <a:rPr lang="en-US"/>
               <a:t>Click to edit Master title style</a:t>
             </a:r>
-            <a:endParaRPr lang="en-US"/>
           </a:p>
         </p:txBody>
       </p:sp>
@@ -766,38 +775,37 @@
           <a:p>
             <a:pPr lvl="0"/>
             <a:r>
-              <a:rPr lang="en-US" smtClean="0"/>
+              <a:rPr lang="en-US"/>
               <a:t>Click to edit Master text styles</a:t>
             </a:r>
           </a:p>
           <a:p>
             <a:pPr lvl="1"/>
             <a:r>
-              <a:rPr lang="en-US" smtClean="0"/>
+              <a:rPr lang="en-US"/>
               <a:t>Second level</a:t>
             </a:r>
           </a:p>
           <a:p>
             <a:pPr lvl="2"/>
             <a:r>
-              <a:rPr lang="en-US" smtClean="0"/>
+              <a:rPr lang="en-US"/>
               <a:t>Third level</a:t>
             </a:r>
           </a:p>
           <a:p>
             <a:pPr lvl="3"/>
             <a:r>
-              <a:rPr lang="en-US" smtClean="0"/>
+              <a:rPr lang="en-US"/>
               <a:t>Fourth level</a:t>
             </a:r>
           </a:p>
           <a:p>
             <a:pPr lvl="4"/>
             <a:r>
-              <a:rPr lang="en-US" smtClean="0"/>
+              <a:rPr lang="en-US"/>
               <a:t>Fifth level</a:t>
             </a:r>
-            <a:endParaRPr lang="en-US"/>
           </a:p>
         </p:txBody>
       </p:sp>
@@ -818,7 +826,7 @@
           <a:p>
             <a:fld id="{5BCAD085-E8A6-8845-BD4E-CB4CCA059FC4}" type="datetimeFigureOut">
               <a:rPr lang="en-US" smtClean="0"/>
-              <a:t>1/27/13</a:t>
+              <a:t>6/20/2026</a:t>
             </a:fld>
             <a:endParaRPr lang="en-US"/>
           </a:p>
@@ -921,10 +929,9 @@
           </a:lstStyle>
           <a:p>
             <a:r>
-              <a:rPr lang="en-US" smtClean="0"/>
+              <a:rPr lang="en-US"/>
               <a:t>Click to edit Master title style</a:t>
             </a:r>
-            <a:endParaRPr lang="en-US"/>
           </a:p>
         </p:txBody>
       </p:sp>
@@ -1041,7 +1048,7 @@
           <a:p>
             <a:pPr lvl="0"/>
             <a:r>
-              <a:rPr lang="en-US" smtClean="0"/>
+              <a:rPr lang="en-US"/>
               <a:t>Click to edit Master text styles</a:t>
             </a:r>
           </a:p>
@@ -1064,7 +1071,7 @@
           <a:p>
             <a:fld id="{5BCAD085-E8A6-8845-BD4E-CB4CCA059FC4}" type="datetimeFigureOut">
               <a:rPr lang="en-US" smtClean="0"/>
-              <a:t>1/27/13</a:t>
+              <a:t>6/20/2026</a:t>
             </a:fld>
             <a:endParaRPr lang="en-US"/>
           </a:p>
@@ -1158,10 +1165,9 @@
           <a:lstStyle/>
           <a:p>
             <a:r>
-              <a:rPr lang="en-US" smtClean="0"/>
+              <a:rPr lang="en-US"/>
               <a:t>Click to edit Master title style</a:t>
             </a:r>
-            <a:endParaRPr lang="en-US"/>
           </a:p>
         </p:txBody>
       </p:sp>
@@ -1215,38 +1221,37 @@
           <a:p>
             <a:pPr lvl="0"/>
             <a:r>
-              <a:rPr lang="en-US" smtClean="0"/>
+              <a:rPr lang="en-US"/>
               <a:t>Click to edit Master text styles</a:t>
             </a:r>
           </a:p>
           <a:p>
             <a:pPr lvl="1"/>
             <a:r>
-              <a:rPr lang="en-US" smtClean="0"/>
+              <a:rPr lang="en-US"/>
               <a:t>Second level</a:t>
             </a:r>
           </a:p>
           <a:p>
             <a:pPr lvl="2"/>
             <a:r>
-              <a:rPr lang="en-US" smtClean="0"/>
+              <a:rPr lang="en-US"/>
               <a:t>Third level</a:t>
             </a:r>
           </a:p>
           <a:p>
             <a:pPr lvl="3"/>
             <a:r>
-              <a:rPr lang="en-US" smtClean="0"/>
+              <a:rPr lang="en-US"/>
               <a:t>Fourth level</a:t>
             </a:r>
           </a:p>
           <a:p>
             <a:pPr lvl="4"/>
             <a:r>
-              <a:rPr lang="en-US" smtClean="0"/>
+              <a:rPr lang="en-US"/>
               <a:t>Fifth level</a:t>
             </a:r>
-            <a:endParaRPr lang="en-US"/>
           </a:p>
         </p:txBody>
       </p:sp>
@@ -1300,38 +1305,37 @@
           <a:p>
             <a:pPr lvl="0"/>
             <a:r>
-              <a:rPr lang="en-US" smtClean="0"/>
+              <a:rPr lang="en-US"/>
               <a:t>Click to edit Master text styles</a:t>
             </a:r>
           </a:p>
           <a:p>
             <a:pPr lvl="1"/>
             <a:r>
-              <a:rPr lang="en-US" smtClean="0"/>
+              <a:rPr lang="en-US"/>
               <a:t>Second level</a:t>
             </a:r>
           </a:p>
           <a:p>
             <a:pPr lvl="2"/>
             <a:r>
-              <a:rPr lang="en-US" smtClean="0"/>
+              <a:rPr lang="en-US"/>
               <a:t>Third level</a:t>
             </a:r>
           </a:p>
           <a:p>
             <a:pPr lvl="3"/>
             <a:r>
-              <a:rPr lang="en-US" smtClean="0"/>
+              <a:rPr lang="en-US"/>
               <a:t>Fourth level</a:t>
             </a:r>
           </a:p>
           <a:p>
             <a:pPr lvl="4"/>
             <a:r>
-              <a:rPr lang="en-US" smtClean="0"/>
+              <a:rPr lang="en-US"/>
               <a:t>Fifth level</a:t>
             </a:r>
-            <a:endParaRPr lang="en-US"/>
           </a:p>
         </p:txBody>
       </p:sp>
@@ -1352,7 +1356,7 @@
           <a:p>
             <a:fld id="{5BCAD085-E8A6-8845-BD4E-CB4CCA059FC4}" type="datetimeFigureOut">
               <a:rPr lang="en-US" smtClean="0"/>
-              <a:t>1/27/13</a:t>
+              <a:t>6/20/2026</a:t>
             </a:fld>
             <a:endParaRPr lang="en-US"/>
           </a:p>
@@ -1450,10 +1454,9 @@
           </a:lstStyle>
           <a:p>
             <a:r>
-              <a:rPr lang="en-US" smtClean="0"/>
+              <a:rPr lang="en-US"/>
               <a:t>Click to edit Master title style</a:t>
             </a:r>
-            <a:endParaRPr lang="en-US"/>
           </a:p>
         </p:txBody>
       </p:sp>
@@ -1516,7 +1519,7 @@
           <a:p>
             <a:pPr lvl="0"/>
             <a:r>
-              <a:rPr lang="en-US" smtClean="0"/>
+              <a:rPr lang="en-US"/>
               <a:t>Click to edit Master text styles</a:t>
             </a:r>
           </a:p>
@@ -1572,38 +1575,37 @@
           <a:p>
             <a:pPr lvl="0"/>
             <a:r>
-              <a:rPr lang="en-US" smtClean="0"/>
+              <a:rPr lang="en-US"/>
               <a:t>Click to edit Master text styles</a:t>
             </a:r>
           </a:p>
           <a:p>
             <a:pPr lvl="1"/>
             <a:r>
-              <a:rPr lang="en-US" smtClean="0"/>
+              <a:rPr lang="en-US"/>
               <a:t>Second level</a:t>
             </a:r>
           </a:p>
           <a:p>
             <a:pPr lvl="2"/>
             <a:r>
-              <a:rPr lang="en-US" smtClean="0"/>
+              <a:rPr lang="en-US"/>
               <a:t>Third level</a:t>
             </a:r>
           </a:p>
           <a:p>
             <a:pPr lvl="3"/>
             <a:r>
-              <a:rPr lang="en-US" smtClean="0"/>
+              <a:rPr lang="en-US"/>
               <a:t>Fourth level</a:t>
             </a:r>
           </a:p>
           <a:p>
             <a:pPr lvl="4"/>
             <a:r>
-              <a:rPr lang="en-US" smtClean="0"/>
+              <a:rPr lang="en-US"/>
               <a:t>Fifth level</a:t>
             </a:r>
-            <a:endParaRPr lang="en-US"/>
           </a:p>
         </p:txBody>
       </p:sp>
@@ -1666,7 +1668,7 @@
           <a:p>
             <a:pPr lvl="0"/>
             <a:r>
-              <a:rPr lang="en-US" smtClean="0"/>
+              <a:rPr lang="en-US"/>
               <a:t>Click to edit Master text styles</a:t>
             </a:r>
           </a:p>
@@ -1722,38 +1724,37 @@
           <a:p>
             <a:pPr lvl="0"/>
             <a:r>
-              <a:rPr lang="en-US" smtClean="0"/>
+              <a:rPr lang="en-US"/>
               <a:t>Click to edit Master text styles</a:t>
             </a:r>
           </a:p>
           <a:p>
             <a:pPr lvl="1"/>
             <a:r>
-              <a:rPr lang="en-US" smtClean="0"/>
+              <a:rPr lang="en-US"/>
               <a:t>Second level</a:t>
             </a:r>
           </a:p>
           <a:p>
             <a:pPr lvl="2"/>
             <a:r>
-              <a:rPr lang="en-US" smtClean="0"/>
+              <a:rPr lang="en-US"/>
               <a:t>Third level</a:t>
             </a:r>
           </a:p>
           <a:p>
             <a:pPr lvl="3"/>
             <a:r>
-              <a:rPr lang="en-US" smtClean="0"/>
+              <a:rPr lang="en-US"/>
               <a:t>Fourth level</a:t>
             </a:r>
           </a:p>
           <a:p>
             <a:pPr lvl="4"/>
             <a:r>
-              <a:rPr lang="en-US" smtClean="0"/>
+              <a:rPr lang="en-US"/>
               <a:t>Fifth level</a:t>
             </a:r>
-            <a:endParaRPr lang="en-US"/>
           </a:p>
         </p:txBody>
       </p:sp>
@@ -1774,7 +1775,7 @@
           <a:p>
             <a:fld id="{5BCAD085-E8A6-8845-BD4E-CB4CCA059FC4}" type="datetimeFigureOut">
               <a:rPr lang="en-US" smtClean="0"/>
-              <a:t>1/27/13</a:t>
+              <a:t>6/20/2026</a:t>
             </a:fld>
             <a:endParaRPr lang="en-US"/>
           </a:p>
@@ -1868,10 +1869,9 @@
           <a:lstStyle/>
           <a:p>
             <a:r>
-              <a:rPr lang="en-US" smtClean="0"/>
+              <a:rPr lang="en-US"/>
               <a:t>Click to edit Master title style</a:t>
             </a:r>
-            <a:endParaRPr lang="en-US"/>
           </a:p>
         </p:txBody>
       </p:sp>
@@ -1892,7 +1892,7 @@
           <a:p>
             <a:fld id="{5BCAD085-E8A6-8845-BD4E-CB4CCA059FC4}" type="datetimeFigureOut">
               <a:rPr lang="en-US" smtClean="0"/>
-              <a:t>1/27/13</a:t>
+              <a:t>6/20/2026</a:t>
             </a:fld>
             <a:endParaRPr lang="en-US"/>
           </a:p>
@@ -1987,7 +1987,7 @@
           <a:p>
             <a:fld id="{5BCAD085-E8A6-8845-BD4E-CB4CCA059FC4}" type="datetimeFigureOut">
               <a:rPr lang="en-US" smtClean="0"/>
-              <a:t>1/27/13</a:t>
+              <a:t>6/20/2026</a:t>
             </a:fld>
             <a:endParaRPr lang="en-US"/>
           </a:p>
@@ -2090,10 +2090,9 @@
           </a:lstStyle>
           <a:p>
             <a:r>
-              <a:rPr lang="en-US" smtClean="0"/>
+              <a:rPr lang="en-US"/>
               <a:t>Click to edit Master title style</a:t>
             </a:r>
-            <a:endParaRPr lang="en-US"/>
           </a:p>
         </p:txBody>
       </p:sp>
@@ -2147,38 +2146,37 @@
           <a:p>
             <a:pPr lvl="0"/>
             <a:r>
-              <a:rPr lang="en-US" smtClean="0"/>
+              <a:rPr lang="en-US"/>
               <a:t>Click to edit Master text styles</a:t>
             </a:r>
           </a:p>
           <a:p>
             <a:pPr lvl="1"/>
             <a:r>
-              <a:rPr lang="en-US" smtClean="0"/>
+              <a:rPr lang="en-US"/>
               <a:t>Second level</a:t>
             </a:r>
           </a:p>
           <a:p>
             <a:pPr lvl="2"/>
             <a:r>
-              <a:rPr lang="en-US" smtClean="0"/>
+              <a:rPr lang="en-US"/>
               <a:t>Third level</a:t>
             </a:r>
           </a:p>
           <a:p>
             <a:pPr lvl="3"/>
             <a:r>
-              <a:rPr lang="en-US" smtClean="0"/>
+              <a:rPr lang="en-US"/>
               <a:t>Fourth level</a:t>
             </a:r>
           </a:p>
           <a:p>
             <a:pPr lvl="4"/>
             <a:r>
-              <a:rPr lang="en-US" smtClean="0"/>
+              <a:rPr lang="en-US"/>
               <a:t>Fifth level</a:t>
             </a:r>
-            <a:endParaRPr lang="en-US"/>
           </a:p>
         </p:txBody>
       </p:sp>
@@ -2241,7 +2239,7 @@
           <a:p>
             <a:pPr lvl="0"/>
             <a:r>
-              <a:rPr lang="en-US" smtClean="0"/>
+              <a:rPr lang="en-US"/>
               <a:t>Click to edit Master text styles</a:t>
             </a:r>
           </a:p>
@@ -2264,7 +2262,7 @@
           <a:p>
             <a:fld id="{5BCAD085-E8A6-8845-BD4E-CB4CCA059FC4}" type="datetimeFigureOut">
               <a:rPr lang="en-US" smtClean="0"/>
-              <a:t>1/27/13</a:t>
+              <a:t>6/20/2026</a:t>
             </a:fld>
             <a:endParaRPr lang="en-US"/>
           </a:p>
@@ -2367,10 +2365,9 @@
           </a:lstStyle>
           <a:p>
             <a:r>
-              <a:rPr lang="en-US" smtClean="0"/>
+              <a:rPr lang="en-US"/>
               <a:t>Click to edit Master title style</a:t>
             </a:r>
-            <a:endParaRPr lang="en-US"/>
           </a:p>
         </p:txBody>
       </p:sp>
@@ -2494,7 +2491,7 @@
           <a:p>
             <a:pPr lvl="0"/>
             <a:r>
-              <a:rPr lang="en-US" smtClean="0"/>
+              <a:rPr lang="en-US"/>
               <a:t>Click to edit Master text styles</a:t>
             </a:r>
           </a:p>
@@ -2517,7 +2514,7 @@
           <a:p>
             <a:fld id="{5BCAD085-E8A6-8845-BD4E-CB4CCA059FC4}" type="datetimeFigureOut">
               <a:rPr lang="en-US" smtClean="0"/>
-              <a:t>1/27/13</a:t>
+              <a:t>6/20/2026</a:t>
             </a:fld>
             <a:endParaRPr lang="en-US"/>
           </a:p>
@@ -2626,10 +2623,9 @@
           <a:lstStyle/>
           <a:p>
             <a:r>
-              <a:rPr lang="en-US" smtClean="0"/>
+              <a:rPr lang="en-US"/>
               <a:t>Click to edit Master title style</a:t>
             </a:r>
-            <a:endParaRPr lang="en-US"/>
           </a:p>
         </p:txBody>
       </p:sp>
@@ -2660,38 +2656,37 @@
           <a:p>
             <a:pPr lvl="0"/>
             <a:r>
-              <a:rPr lang="en-US" smtClean="0"/>
+              <a:rPr lang="en-US"/>
               <a:t>Click to edit Master text styles</a:t>
             </a:r>
           </a:p>
           <a:p>
             <a:pPr lvl="1"/>
             <a:r>
-              <a:rPr lang="en-US" smtClean="0"/>
+              <a:rPr lang="en-US"/>
               <a:t>Second level</a:t>
             </a:r>
           </a:p>
           <a:p>
             <a:pPr lvl="2"/>
             <a:r>
-              <a:rPr lang="en-US" smtClean="0"/>
+              <a:rPr lang="en-US"/>
               <a:t>Third level</a:t>
             </a:r>
           </a:p>
           <a:p>
             <a:pPr lvl="3"/>
             <a:r>
-              <a:rPr lang="en-US" smtClean="0"/>
+              <a:rPr lang="en-US"/>
               <a:t>Fourth level</a:t>
             </a:r>
           </a:p>
           <a:p>
             <a:pPr lvl="4"/>
             <a:r>
-              <a:rPr lang="en-US" smtClean="0"/>
+              <a:rPr lang="en-US"/>
               <a:t>Fifth level</a:t>
             </a:r>
-            <a:endParaRPr lang="en-US"/>
           </a:p>
         </p:txBody>
       </p:sp>
@@ -2730,7 +2725,7 @@
           <a:p>
             <a:fld id="{5BCAD085-E8A6-8845-BD4E-CB4CCA059FC4}" type="datetimeFigureOut">
               <a:rPr lang="en-US" smtClean="0"/>
-              <a:t>1/27/13</a:t>
+              <a:t>6/20/2026</a:t>
             </a:fld>
             <a:endParaRPr lang="en-US"/>
           </a:p>
@@ -3089,7 +3084,7 @@
 </file>
 
 <file path=ppt/slides/slide1.xml><?xml version="1.0" encoding="utf-8"?>
-<p:sld xmlns:a="http://schemas.openxmlformats.org/drawingml/2006/main" xmlns:p="http://schemas.openxmlformats.org/presentationml/2006/main" xmlns:r="http://schemas.openxmlformats.org/officeDocument/2006/relationships">
+<p:sld xmlns:a="http://schemas.openxmlformats.org/drawingml/2006/main" xmlns:r="http://schemas.openxmlformats.org/officeDocument/2006/relationships" xmlns:p="http://schemas.openxmlformats.org/presentationml/2006/main">
   <p:cSld>
     <p:bg>
       <p:bgPr>
@@ -3105,7 +3100,14 @@
         <p:cNvGrpSpPr/>
         <p:nvPr/>
       </p:nvGrpSpPr>
-      <p:grpSpPr/>
+      <p:grpSpPr>
+        <a:xfrm>
+          <a:off x="0" y="0"/>
+          <a:ext cx="0" cy="0"/>
+          <a:chOff x="0" y="0"/>
+          <a:chExt cx="0" cy="0"/>
+        </a:xfrm>
+      </p:grpSpPr>
       <p:sp>
         <p:nvSpPr>
           <p:cNvPr id="2" name="TextBox 1"/>
@@ -3115,7 +3117,7 @@
         <p:spPr>
           <a:xfrm>
             <a:off x="731520" y="1828800"/>
-            <a:ext cx="10515600" cy="2011680"/>
+            <a:ext cx="10515600" cy="1661993"/>
           </a:xfrm>
           <a:prstGeom prst="rect">
             <a:avLst/>
@@ -3137,22 +3139,35 @@
               </a:defRPr>
             </a:pPr>
             <a:r>
+              <a:rPr dirty="0"/>
               <a:t>САМОСТОЯТЕЛЬНАЯ РАБОТА • ТПР</a:t>
             </a:r>
           </a:p>
           <a:p>
-            <a:br/>
-            <a:pPr>
-              <a:defRPr sz="4400" b="1">
-                <a:solidFill>
-                  <a:srgbClr val="0F172A"/>
-                </a:solidFill>
-                <a:latin typeface="Arial"/>
-              </a:defRPr>
-            </a:pPr>
-            <a:r>
-              <a:t>Метод минимального элемента</a:t>
-            </a:r>
+            <a:br>
+              <a:rPr sz="4400" b="1" dirty="0"/>
+            </a:br>
+            <a:r>
+              <a:rPr sz="4400" b="1" dirty="0" err="1"/>
+              <a:t>Метод</a:t>
+            </a:r>
+            <a:r>
+              <a:rPr sz="4400" b="1" dirty="0"/>
+              <a:t> </a:t>
+            </a:r>
+            <a:r>
+              <a:rPr sz="4400" b="1" dirty="0" err="1"/>
+              <a:t>минимального</a:t>
+            </a:r>
+            <a:r>
+              <a:rPr sz="4400" b="1" dirty="0"/>
+              <a:t> </a:t>
+            </a:r>
+            <a:r>
+              <a:rPr sz="4400" b="1" dirty="0" err="1"/>
+              <a:t>элемента</a:t>
+            </a:r>
+            <a:endParaRPr sz="4400" b="1" dirty="0"/>
           </a:p>
         </p:txBody>
       </p:sp>
@@ -3196,6 +3211,7 @@
           <a:lstStyle/>
           <a:p>
             <a:pPr algn="ctr"/>
+            <a:endParaRPr/>
           </a:p>
         </p:txBody>
       </p:sp>
@@ -3248,7 +3264,7 @@
 </file>
 
 <file path=ppt/slides/slide10.xml><?xml version="1.0" encoding="utf-8"?>
-<p:sld xmlns:a="http://schemas.openxmlformats.org/drawingml/2006/main" xmlns:p="http://schemas.openxmlformats.org/presentationml/2006/main" xmlns:r="http://schemas.openxmlformats.org/officeDocument/2006/relationships">
+<p:sld xmlns:a="http://schemas.openxmlformats.org/drawingml/2006/main" xmlns:r="http://schemas.openxmlformats.org/officeDocument/2006/relationships" xmlns:p="http://schemas.openxmlformats.org/presentationml/2006/main">
   <p:cSld>
     <p:bg>
       <p:bgPr>
@@ -3264,7 +3280,14 @@
         <p:cNvGrpSpPr/>
         <p:nvPr/>
       </p:nvGrpSpPr>
-      <p:grpSpPr/>
+      <p:grpSpPr>
+        <a:xfrm>
+          <a:off x="0" y="0"/>
+          <a:ext cx="0" cy="0"/>
+          <a:chOff x="0" y="0"/>
+          <a:chExt cx="0" cy="0"/>
+        </a:xfrm>
+      </p:grpSpPr>
       <p:sp>
         <p:nvSpPr>
           <p:cNvPr id="2" name="TextBox 1"/>
@@ -3377,6 +3400,7 @@
           <a:lstStyle/>
           <a:p>
             <a:pPr algn="ctr"/>
+            <a:endParaRPr/>
           </a:p>
         </p:txBody>
       </p:sp>
@@ -3416,14 +3440,6 @@
           </a:p>
           <a:p>
             <a:br/>
-            <a:pPr>
-              <a:defRPr sz="2200">
-                <a:solidFill>
-                  <a:srgbClr val="0F172A"/>
-                </a:solidFill>
-                <a:latin typeface="Calibri"/>
-              </a:defRPr>
-            </a:pPr>
             <a:r>
               <a:t>• Простота расчетов.</a:t>
             </a:r>
@@ -3478,14 +3494,6 @@
           </a:p>
           <a:p>
             <a:br/>
-            <a:pPr>
-              <a:defRPr sz="2200">
-                <a:solidFill>
-                  <a:srgbClr val="0F172A"/>
-                </a:solidFill>
-                <a:latin typeface="Calibri"/>
-              </a:defRPr>
-            </a:pPr>
             <a:r>
               <a:t>• Локальная «жадность».</a:t>
             </a:r>
@@ -3495,7 +3503,7 @@
             </a:r>
             <a:br/>
             <a:r>
-              <a:t>• Уступает по качеству методу аппроксимации Фогеля.</a:t>
+              <a:t>• Не гарантирует глобальный минимум стоимости.</a:t>
             </a:r>
           </a:p>
         </p:txBody>
@@ -3509,7 +3517,7 @@
 </file>
 
 <file path=ppt/slides/slide11.xml><?xml version="1.0" encoding="utf-8"?>
-<p:sld xmlns:a="http://schemas.openxmlformats.org/drawingml/2006/main" xmlns:p="http://schemas.openxmlformats.org/presentationml/2006/main" xmlns:r="http://schemas.openxmlformats.org/officeDocument/2006/relationships">
+<p:sld xmlns:a="http://schemas.openxmlformats.org/drawingml/2006/main" xmlns:r="http://schemas.openxmlformats.org/officeDocument/2006/relationships" xmlns:p="http://schemas.openxmlformats.org/presentationml/2006/main">
   <p:cSld>
     <p:bg>
       <p:bgPr>
@@ -3525,7 +3533,14 @@
         <p:cNvGrpSpPr/>
         <p:nvPr/>
       </p:nvGrpSpPr>
-      <p:grpSpPr/>
+      <p:grpSpPr>
+        <a:xfrm>
+          <a:off x="0" y="0"/>
+          <a:ext cx="0" cy="0"/>
+          <a:chOff x="0" y="0"/>
+          <a:chExt cx="0" cy="0"/>
+        </a:xfrm>
+      </p:grpSpPr>
       <p:sp>
         <p:nvSpPr>
           <p:cNvPr id="2" name="TextBox 1"/>
@@ -3638,6 +3653,7 @@
           <a:lstStyle/>
           <a:p>
             <a:pPr algn="ctr"/>
+            <a:endParaRPr/>
           </a:p>
         </p:txBody>
       </p:sp>
@@ -3677,14 +3693,6 @@
           </a:p>
           <a:p>
             <a:br/>
-            <a:pPr>
-              <a:defRPr sz="2400">
-                <a:solidFill>
-                  <a:srgbClr val="0F172A"/>
-                </a:solidFill>
-                <a:latin typeface="Calibri"/>
-              </a:defRPr>
-            </a:pPr>
             <a:r>
               <a:t>Оптимальный баланс простоты и качества начального решения.</a:t>
             </a:r>
@@ -3705,7 +3713,7 @@
 </file>
 
 <file path=ppt/slides/slide2.xml><?xml version="1.0" encoding="utf-8"?>
-<p:sld xmlns:a="http://schemas.openxmlformats.org/drawingml/2006/main" xmlns:p="http://schemas.openxmlformats.org/presentationml/2006/main" xmlns:r="http://schemas.openxmlformats.org/officeDocument/2006/relationships">
+<p:sld xmlns:a="http://schemas.openxmlformats.org/drawingml/2006/main" xmlns:r="http://schemas.openxmlformats.org/officeDocument/2006/relationships" xmlns:p="http://schemas.openxmlformats.org/presentationml/2006/main">
   <p:cSld>
     <p:bg>
       <p:bgPr>
@@ -3721,7 +3729,14 @@
         <p:cNvGrpSpPr/>
         <p:nvPr/>
       </p:nvGrpSpPr>
-      <p:grpSpPr/>
+      <p:grpSpPr>
+        <a:xfrm>
+          <a:off x="0" y="0"/>
+          <a:ext cx="0" cy="0"/>
+          <a:chOff x="0" y="0"/>
+          <a:chExt cx="0" cy="0"/>
+        </a:xfrm>
+      </p:grpSpPr>
       <p:sp>
         <p:nvSpPr>
           <p:cNvPr id="2" name="TextBox 1"/>
@@ -3834,6 +3849,7 @@
           <a:lstStyle/>
           <a:p>
             <a:pPr algn="ctr"/>
+            <a:endParaRPr/>
           </a:p>
         </p:txBody>
       </p:sp>
@@ -3873,14 +3889,6 @@
           </a:p>
           <a:p>
             <a:br/>
-            <a:pPr>
-              <a:defRPr sz="2200">
-                <a:solidFill>
-                  <a:srgbClr val="475569"/>
-                </a:solidFill>
-                <a:latin typeface="Calibri"/>
-              </a:defRPr>
-            </a:pPr>
             <a:r>
               <a:t>Оптимальная доставка однородного груза от поставщиков к потребителям.</a:t>
             </a:r>
@@ -3935,34 +3943,174 @@
             </a:r>
           </a:p>
           <a:p>
+            <a:pPr>
+              <a:defRPr sz="2400" b="1"/>
+            </a:pPr>
+            <a:r>
+              <a:rPr sz="2400" b="1">
+                <a:solidFill>
+                  <a:srgbClr val="2563EB"/>
+                </a:solidFill>
+                <a:latin typeface="Arial"/>
+              </a:rPr>
+              <a:t>
+Z = ∑∑ c</a:t>
+            </a:r>
+            <a:r>
+              <a:rPr sz="1600" b="1" baseline="-25000">
+                <a:solidFill>
+                  <a:srgbClr val="2563EB"/>
+                </a:solidFill>
+                <a:latin typeface="Arial"/>
+              </a:rPr>
+              <a:t>ij</a:t>
+            </a:r>
+            <a:r>
+              <a:rPr sz="2400" b="1">
+                <a:solidFill>
+                  <a:srgbClr val="2563EB"/>
+                </a:solidFill>
+                <a:latin typeface="Arial"/>
+              </a:rPr>
+              <a:t> • x</a:t>
+            </a:r>
+            <a:r>
+              <a:rPr sz="1600" b="1" baseline="-25000">
+                <a:solidFill>
+                  <a:srgbClr val="2563EB"/>
+                </a:solidFill>
+                <a:latin typeface="Arial"/>
+              </a:rPr>
+              <a:t>ij</a:t>
+            </a:r>
+            <a:r>
+              <a:rPr sz="2400" b="1">
+                <a:solidFill>
+                  <a:srgbClr val="2563EB"/>
+                </a:solidFill>
+                <a:latin typeface="Arial"/>
+              </a:rPr>
+              <a:t>  →  min</a:t>
+            </a:r>
+          </a:p>
+          <a:p>
             <a:br/>
+            <a:r>
+              <a:t>Ограничения:</a:t>
+            </a:r>
+          </a:p>
+          <a:p>
             <a:pPr>
-              <a:defRPr sz="2400" b="1">
+              <a:defRPr sz="2200" b="1"/>
+            </a:pPr>
+            <a:r>
+              <a:rPr sz="2200" b="1">
                 <a:solidFill>
                   <a:srgbClr val="2563EB"/>
                 </a:solidFill>
                 <a:latin typeface="Arial"/>
-              </a:defRPr>
+              </a:rPr>
+              <a:t>∑ x</a:t>
+            </a:r>
+            <a:r>
+              <a:rPr sz="1500" b="1" baseline="-25000">
+                <a:solidFill>
+                  <a:srgbClr val="2563EB"/>
+                </a:solidFill>
+                <a:latin typeface="Arial"/>
+              </a:rPr>
+              <a:t>ij</a:t>
+            </a:r>
+            <a:r>
+              <a:rPr sz="2200" b="1">
+                <a:solidFill>
+                  <a:srgbClr val="2563EB"/>
+                </a:solidFill>
+                <a:latin typeface="Arial"/>
+              </a:rPr>
+              <a:t> = a</a:t>
+            </a:r>
+            <a:r>
+              <a:rPr sz="1500" b="1" baseline="-25000">
+                <a:solidFill>
+                  <a:srgbClr val="2563EB"/>
+                </a:solidFill>
+                <a:latin typeface="Arial"/>
+              </a:rPr>
+              <a:t>i</a:t>
+            </a:r>
+          </a:p>
+          <a:p>
+            <a:pPr>
+              <a:defRPr sz="2200" b="1"/>
             </a:pPr>
             <a:r>
-              <a:t>Z = ∑∑ c_ij • x_ij  →  min</a:t>
-            </a:r>
-            <a:br/>
-            <a:br/>
-            <a:r>
-              <a:t>Ограничения:</a:t>
-            </a:r>
-            <a:br/>
-            <a:r>
-              <a:t>∑ x_ij = a_i</a:t>
-            </a:r>
-            <a:br/>
-            <a:r>
-              <a:t>∑ x_ij = b_j</a:t>
-            </a:r>
-            <a:br/>
-            <a:r>
-              <a:t>x_ij ≥ 0</a:t>
+              <a:rPr sz="2200" b="1">
+                <a:solidFill>
+                  <a:srgbClr val="2563EB"/>
+                </a:solidFill>
+                <a:latin typeface="Arial"/>
+              </a:rPr>
+              <a:t>∑ x</a:t>
+            </a:r>
+            <a:r>
+              <a:rPr sz="1500" b="1" baseline="-25000">
+                <a:solidFill>
+                  <a:srgbClr val="2563EB"/>
+                </a:solidFill>
+                <a:latin typeface="Arial"/>
+              </a:rPr>
+              <a:t>ij</a:t>
+            </a:r>
+            <a:r>
+              <a:rPr sz="2200" b="1">
+                <a:solidFill>
+                  <a:srgbClr val="2563EB"/>
+                </a:solidFill>
+                <a:latin typeface="Arial"/>
+              </a:rPr>
+              <a:t> = b</a:t>
+            </a:r>
+            <a:r>
+              <a:rPr sz="1500" b="1" baseline="-25000">
+                <a:solidFill>
+                  <a:srgbClr val="2563EB"/>
+                </a:solidFill>
+                <a:latin typeface="Arial"/>
+              </a:rPr>
+              <a:t>j</a:t>
+            </a:r>
+          </a:p>
+          <a:p>
+            <a:pPr>
+              <a:defRPr sz="2200" b="1"/>
+            </a:pPr>
+            <a:r>
+              <a:rPr sz="2200" b="1">
+                <a:solidFill>
+                  <a:srgbClr val="2563EB"/>
+                </a:solidFill>
+                <a:latin typeface="Arial"/>
+              </a:rPr>
+              <a:t>x</a:t>
+            </a:r>
+            <a:r>
+              <a:rPr sz="1500" b="1" baseline="-25000">
+                <a:solidFill>
+                  <a:srgbClr val="2563EB"/>
+                </a:solidFill>
+                <a:latin typeface="Arial"/>
+              </a:rPr>
+              <a:t>ij</a:t>
+            </a:r>
+            <a:r>
+              <a:rPr sz="2200" b="1">
+                <a:solidFill>
+                  <a:srgbClr val="2563EB"/>
+                </a:solidFill>
+                <a:latin typeface="Arial"/>
+              </a:rPr>
+              <a:t> ≥ 0</a:t>
             </a:r>
           </a:p>
         </p:txBody>
@@ -3976,7 +4124,7 @@
 </file>
 
 <file path=ppt/slides/slide3.xml><?xml version="1.0" encoding="utf-8"?>
-<p:sld xmlns:a="http://schemas.openxmlformats.org/drawingml/2006/main" xmlns:p="http://schemas.openxmlformats.org/presentationml/2006/main" xmlns:r="http://schemas.openxmlformats.org/officeDocument/2006/relationships">
+<p:sld xmlns:a="http://schemas.openxmlformats.org/drawingml/2006/main" xmlns:r="http://schemas.openxmlformats.org/officeDocument/2006/relationships" xmlns:p="http://schemas.openxmlformats.org/presentationml/2006/main">
   <p:cSld>
     <p:bg>
       <p:bgPr>
@@ -3992,7 +4140,14 @@
         <p:cNvGrpSpPr/>
         <p:nvPr/>
       </p:nvGrpSpPr>
-      <p:grpSpPr/>
+      <p:grpSpPr>
+        <a:xfrm>
+          <a:off x="0" y="0"/>
+          <a:ext cx="0" cy="0"/>
+          <a:chOff x="0" y="0"/>
+          <a:chExt cx="0" cy="0"/>
+        </a:xfrm>
+      </p:grpSpPr>
       <p:sp>
         <p:nvSpPr>
           <p:cNvPr id="2" name="TextBox 1"/>
@@ -4105,6 +4260,7 @@
           <a:lstStyle/>
           <a:p>
             <a:pPr algn="ctr"/>
+            <a:endParaRPr/>
           </a:p>
         </p:txBody>
       </p:sp>
@@ -4139,9 +4295,10 @@
               </a:defRPr>
             </a:pPr>
             <a:r>
-              <a:t>1. Быстрый старт: Мгновенное построение допустимого плана перевозок.</a:t>
+              <a:t>1. Быстрое построение первоначального допустимого плана перевозок.</a:t>
             </a:r>
             <a:br/>
+            <a:endParaRPr/>
           </a:p>
           <a:p>
             <a:pPr>
@@ -4153,9 +4310,10 @@
               </a:defRPr>
             </a:pPr>
             <a:r>
-              <a:t>2. Экономия: План учитывает тарифы и изначально близок к оптимальному.</a:t>
+              <a:t>2. Учет реальных тарифов перевозок при составлении маршрутов.</a:t>
             </a:r>
             <a:br/>
+            <a:endParaRPr/>
           </a:p>
           <a:p>
             <a:pPr>
@@ -4167,9 +4325,10 @@
               </a:defRPr>
             </a:pPr>
             <a:r>
-              <a:t>3. Эффективность: Сокращает количество итераций метода потенциалов.</a:t>
+              <a:t>3. Значительное сокращение количества последующих шагов оптимизации.</a:t>
             </a:r>
             <a:br/>
+            <a:endParaRPr/>
           </a:p>
         </p:txBody>
       </p:sp>
@@ -4182,7 +4341,7 @@
 </file>
 
 <file path=ppt/slides/slide4.xml><?xml version="1.0" encoding="utf-8"?>
-<p:sld xmlns:a="http://schemas.openxmlformats.org/drawingml/2006/main" xmlns:p="http://schemas.openxmlformats.org/presentationml/2006/main" xmlns:r="http://schemas.openxmlformats.org/officeDocument/2006/relationships">
+<p:sld xmlns:a="http://schemas.openxmlformats.org/drawingml/2006/main" xmlns:r="http://schemas.openxmlformats.org/officeDocument/2006/relationships" xmlns:p="http://schemas.openxmlformats.org/presentationml/2006/main">
   <p:cSld>
     <p:bg>
       <p:bgPr>
@@ -4198,7 +4357,14 @@
         <p:cNvGrpSpPr/>
         <p:nvPr/>
       </p:nvGrpSpPr>
-      <p:grpSpPr/>
+      <p:grpSpPr>
+        <a:xfrm>
+          <a:off x="0" y="0"/>
+          <a:ext cx="0" cy="0"/>
+          <a:chOff x="0" y="0"/>
+          <a:chExt cx="0" cy="0"/>
+        </a:xfrm>
+      </p:grpSpPr>
       <p:sp>
         <p:nvSpPr>
           <p:cNvPr id="2" name="TextBox 1"/>
@@ -4311,6 +4477,7 @@
           <a:lstStyle/>
           <a:p>
             <a:pPr algn="ctr"/>
+            <a:endParaRPr/>
           </a:p>
         </p:txBody>
       </p:sp>
@@ -4345,19 +4512,11 @@
               </a:defRPr>
             </a:pPr>
             <a:r>
-              <a:t>Локальный «жадный» выбор:</a:t>
+              <a:t>Локальный («жадный») выбор</a:t>
             </a:r>
           </a:p>
           <a:p>
             <a:br/>
-            <a:pPr>
-              <a:defRPr sz="2400">
-                <a:solidFill>
-                  <a:srgbClr val="0F172A"/>
-                </a:solidFill>
-                <a:latin typeface="Calibri"/>
-              </a:defRPr>
-            </a:pPr>
             <a:r>
               <a:t>Приоритетное заполнение клеток таблицы с наименьшей стоимостью перевозок.</a:t>
             </a:r>
@@ -4378,7 +4537,7 @@
 </file>
 
 <file path=ppt/slides/slide5.xml><?xml version="1.0" encoding="utf-8"?>
-<p:sld xmlns:a="http://schemas.openxmlformats.org/drawingml/2006/main" xmlns:p="http://schemas.openxmlformats.org/presentationml/2006/main" xmlns:r="http://schemas.openxmlformats.org/officeDocument/2006/relationships">
+<p:sld xmlns:a="http://schemas.openxmlformats.org/drawingml/2006/main" xmlns:r="http://schemas.openxmlformats.org/officeDocument/2006/relationships" xmlns:p="http://schemas.openxmlformats.org/presentationml/2006/main">
   <p:cSld>
     <p:bg>
       <p:bgPr>
@@ -4394,7 +4553,14 @@
         <p:cNvGrpSpPr/>
         <p:nvPr/>
       </p:nvGrpSpPr>
-      <p:grpSpPr/>
+      <p:grpSpPr>
+        <a:xfrm>
+          <a:off x="0" y="0"/>
+          <a:ext cx="0" cy="0"/>
+          <a:chOff x="0" y="0"/>
+          <a:chExt cx="0" cy="0"/>
+        </a:xfrm>
+      </p:grpSpPr>
       <p:sp>
         <p:nvSpPr>
           <p:cNvPr id="2" name="TextBox 1"/>
@@ -4507,6 +4673,7 @@
           <a:lstStyle/>
           <a:p>
             <a:pPr algn="ctr"/>
+            <a:endParaRPr/>
           </a:p>
         </p:txBody>
       </p:sp>
@@ -4536,15 +4703,34 @@
               <a:spcAft>
                 <a:spcPts val="1400"/>
               </a:spcAft>
-              <a:defRPr sz="2200">
+              <a:defRPr sz="2200" b="0"/>
+            </a:pPr>
+            <a:r>
+              <a:rPr sz="2200" b="0">
                 <a:solidFill>
                   <a:srgbClr val="0F172A"/>
                 </a:solidFill>
-                <a:latin typeface="Calibri"/>
-              </a:defRPr>
-            </a:pPr>
-            <a:r>
-              <a:t>1. Найти клетку с минимальным тарифом c_ij.</a:t>
+                <a:latin typeface="Arial"/>
+              </a:rPr>
+              <a:t>1. Найти клетку с минимальным тарифом c</a:t>
+            </a:r>
+            <a:r>
+              <a:rPr sz="1500" b="0" baseline="-25000">
+                <a:solidFill>
+                  <a:srgbClr val="0F172A"/>
+                </a:solidFill>
+                <a:latin typeface="Arial"/>
+              </a:rPr>
+              <a:t>ij</a:t>
+            </a:r>
+            <a:r>
+              <a:rPr sz="2200" b="0">
+                <a:solidFill>
+                  <a:srgbClr val="0F172A"/>
+                </a:solidFill>
+                <a:latin typeface="Arial"/>
+              </a:rPr>
+              <a:t>.</a:t>
             </a:r>
           </a:p>
           <a:p>
@@ -4552,15 +4738,70 @@
               <a:spcAft>
                 <a:spcPts val="1400"/>
               </a:spcAft>
-              <a:defRPr sz="2200">
+              <a:defRPr sz="2200" b="0"/>
+            </a:pPr>
+            <a:r>
+              <a:rPr sz="2200" b="0">
                 <a:solidFill>
                   <a:srgbClr val="0F172A"/>
                 </a:solidFill>
-                <a:latin typeface="Calibri"/>
-              </a:defRPr>
-            </a:pPr>
-            <a:r>
-              <a:t>2. Записать объем перевозки x_ij = min(a_i, b_j).</a:t>
+                <a:latin typeface="Arial"/>
+              </a:rPr>
+              <a:t>2. Записать объем перевозки x</a:t>
+            </a:r>
+            <a:r>
+              <a:rPr sz="1500" b="0" baseline="-25000">
+                <a:solidFill>
+                  <a:srgbClr val="0F172A"/>
+                </a:solidFill>
+                <a:latin typeface="Arial"/>
+              </a:rPr>
+              <a:t>ij</a:t>
+            </a:r>
+            <a:r>
+              <a:rPr sz="2200" b="0">
+                <a:solidFill>
+                  <a:srgbClr val="0F172A"/>
+                </a:solidFill>
+                <a:latin typeface="Arial"/>
+              </a:rPr>
+              <a:t> = min(a</a:t>
+            </a:r>
+            <a:r>
+              <a:rPr sz="1500" b="0" baseline="-25000">
+                <a:solidFill>
+                  <a:srgbClr val="0F172A"/>
+                </a:solidFill>
+                <a:latin typeface="Arial"/>
+              </a:rPr>
+              <a:t>i</a:t>
+            </a:r>
+            <a:r>
+              <a:rPr sz="2200" b="0">
+                <a:solidFill>
+                  <a:srgbClr val="0F172A"/>
+                </a:solidFill>
+                <a:latin typeface="Arial"/>
+              </a:rPr>
+              <a:t>, b</a:t>
+            </a:r>
+            <a:r>
+              <a:rPr sz="1500" b="0" baseline="-25000">
+                <a:solidFill>
+                  <a:srgbClr val="0F172A"/>
+                </a:solidFill>
+                <a:latin typeface="Arial"/>
+              </a:rPr>
+              <a:t>j</a:t>
+            </a:r>
+            <a:r>
+              <a:rPr sz="2200" b="0">
+                <a:solidFill>
+                  <a:srgbClr val="0F172A"/>
+                </a:solidFill>
+                <a:latin typeface="Arial"/>
+              </a:rPr>
+              <a:t>).</a:t>
             </a:r>
           </a:p>
           <a:p>
@@ -4568,15 +4809,70 @@
               <a:spcAft>
                 <a:spcPts val="1400"/>
               </a:spcAft>
-              <a:defRPr sz="2200">
+              <a:defRPr sz="2200" b="0"/>
+            </a:pPr>
+            <a:r>
+              <a:rPr sz="2200" b="0">
                 <a:solidFill>
                   <a:srgbClr val="0F172A"/>
                 </a:solidFill>
-                <a:latin typeface="Calibri"/>
-              </a:defRPr>
-            </a:pPr>
-            <a:r>
-              <a:t>3. Вычесть x_ij из запасов a_i и потребностей b_j.</a:t>
+                <a:latin typeface="Arial"/>
+              </a:rPr>
+              <a:t>3. Вычесть x</a:t>
+            </a:r>
+            <a:r>
+              <a:rPr sz="1500" b="0" baseline="-25000">
+                <a:solidFill>
+                  <a:srgbClr val="0F172A"/>
+                </a:solidFill>
+                <a:latin typeface="Arial"/>
+              </a:rPr>
+              <a:t>ij</a:t>
+            </a:r>
+            <a:r>
+              <a:rPr sz="2200" b="0">
+                <a:solidFill>
+                  <a:srgbClr val="0F172A"/>
+                </a:solidFill>
+                <a:latin typeface="Arial"/>
+              </a:rPr>
+              <a:t> из запасов a</a:t>
+            </a:r>
+            <a:r>
+              <a:rPr sz="1500" b="0" baseline="-25000">
+                <a:solidFill>
+                  <a:srgbClr val="0F172A"/>
+                </a:solidFill>
+                <a:latin typeface="Arial"/>
+              </a:rPr>
+              <a:t>i</a:t>
+            </a:r>
+            <a:r>
+              <a:rPr sz="2200" b="0">
+                <a:solidFill>
+                  <a:srgbClr val="0F172A"/>
+                </a:solidFill>
+                <a:latin typeface="Arial"/>
+              </a:rPr>
+              <a:t> и потребностей b</a:t>
+            </a:r>
+            <a:r>
+              <a:rPr sz="1500" b="0" baseline="-25000">
+                <a:solidFill>
+                  <a:srgbClr val="0F172A"/>
+                </a:solidFill>
+                <a:latin typeface="Arial"/>
+              </a:rPr>
+              <a:t>j</a:t>
+            </a:r>
+            <a:r>
+              <a:rPr sz="2200" b="0">
+                <a:solidFill>
+                  <a:srgbClr val="0F172A"/>
+                </a:solidFill>
+                <a:latin typeface="Arial"/>
+              </a:rPr>
+              <a:t>.</a:t>
             </a:r>
           </a:p>
           <a:p>
@@ -4584,30 +4880,65 @@
               <a:spcAft>
                 <a:spcPts val="1400"/>
               </a:spcAft>
-              <a:defRPr sz="2200">
+              <a:defRPr sz="2200" b="0"/>
+            </a:pPr>
+            <a:r>
+              <a:rPr sz="2200" b="0">
                 <a:solidFill>
                   <a:srgbClr val="0F172A"/>
                 </a:solidFill>
-                <a:latin typeface="Calibri"/>
-              </a:defRPr>
+                <a:latin typeface="Arial"/>
+              </a:rPr>
+              <a:t>4. Вычеркнуть удовлетворенную строку (a</a:t>
+            </a:r>
+            <a:r>
+              <a:rPr sz="1500" b="0" baseline="-25000">
+                <a:solidFill>
+                  <a:srgbClr val="0F172A"/>
+                </a:solidFill>
+                <a:latin typeface="Arial"/>
+              </a:rPr>
+              <a:t>i</a:t>
+            </a:r>
+            <a:r>
+              <a:rPr sz="2200" b="0">
+                <a:solidFill>
+                  <a:srgbClr val="0F172A"/>
+                </a:solidFill>
+                <a:latin typeface="Arial"/>
+              </a:rPr>
+              <a:t>=0) или столбец (b</a:t>
+            </a:r>
+            <a:r>
+              <a:rPr sz="1500" b="0" baseline="-25000">
+                <a:solidFill>
+                  <a:srgbClr val="0F172A"/>
+                </a:solidFill>
+                <a:latin typeface="Arial"/>
+              </a:rPr>
+              <a:t>j</a:t>
+            </a:r>
+            <a:r>
+              <a:rPr sz="2200" b="0">
+                <a:solidFill>
+                  <a:srgbClr val="0F172A"/>
+                </a:solidFill>
+                <a:latin typeface="Arial"/>
+              </a:rPr>
+              <a:t>=0).</a:t>
+            </a:r>
+          </a:p>
+          <a:p>
+            <a:pPr>
+              <a:defRPr sz="2200" b="0"/>
             </a:pPr>
             <a:r>
-              <a:t>4. Вычеркнуть удовлетворенную строку (a_i=0) или столбец (b_j=0).</a:t>
-            </a:r>
-          </a:p>
-          <a:p>
-            <a:pPr>
-              <a:spcAft>
-                <a:spcPts val="1400"/>
-              </a:spcAft>
-              <a:defRPr sz="2200">
+              <a:rPr sz="2200" b="0">
                 <a:solidFill>
                   <a:srgbClr val="0F172A"/>
                 </a:solidFill>
-                <a:latin typeface="Calibri"/>
-              </a:defRPr>
-            </a:pPr>
-            <a:r>
+                <a:latin typeface="Arial"/>
+              </a:rPr>
               <a:t>5. Повторять до полного распределения всех грузов.</a:t>
             </a:r>
           </a:p>
@@ -4622,7 +4953,7 @@
 </file>
 
 <file path=ppt/slides/slide6.xml><?xml version="1.0" encoding="utf-8"?>
-<p:sld xmlns:a="http://schemas.openxmlformats.org/drawingml/2006/main" xmlns:p="http://schemas.openxmlformats.org/presentationml/2006/main" xmlns:r="http://schemas.openxmlformats.org/officeDocument/2006/relationships">
+<p:sld xmlns:a="http://schemas.openxmlformats.org/drawingml/2006/main" xmlns:r="http://schemas.openxmlformats.org/officeDocument/2006/relationships" xmlns:p="http://schemas.openxmlformats.org/presentationml/2006/main">
   <p:cSld>
     <p:bg>
       <p:bgPr>
@@ -4638,7 +4969,14 @@
         <p:cNvGrpSpPr/>
         <p:nvPr/>
       </p:nvGrpSpPr>
-      <p:grpSpPr/>
+      <p:grpSpPr>
+        <a:xfrm>
+          <a:off x="0" y="0"/>
+          <a:ext cx="0" cy="0"/>
+          <a:chOff x="0" y="0"/>
+          <a:chExt cx="0" cy="0"/>
+        </a:xfrm>
+      </p:grpSpPr>
       <p:sp>
         <p:nvSpPr>
           <p:cNvPr id="2" name="TextBox 1"/>
@@ -4751,6 +5089,7 @@
           <a:lstStyle/>
           <a:p>
             <a:pPr algn="ctr"/>
+            <a:endParaRPr/>
           </a:p>
         </p:txBody>
       </p:sp>
@@ -4773,11 +5112,41 @@
                 <a:tableStyleId>{5C22544A-7EE6-4342-B048-85BDC9FD1C3A}</a:tableStyleId>
               </a:tblPr>
               <a:tblGrid>
-                <a:gridCol w="2130552"/>
-                <a:gridCol w="1828800"/>
-                <a:gridCol w="1828800"/>
-                <a:gridCol w="1828800"/>
-                <a:gridCol w="1828800"/>
+                <a:gridCol w="1889150">
+                  <a:extLst>
+                    <a:ext uri="{9D8B030D-6E8A-4147-A177-3AD203B41FA5}">
+                      <a16:colId xmlns:a16="http://schemas.microsoft.com/office/drawing/2014/main" val="20000"/>
+                    </a:ext>
+                  </a:extLst>
+                </a:gridCol>
+                <a:gridCol w="1889150">
+                  <a:extLst>
+                    <a:ext uri="{9D8B030D-6E8A-4147-A177-3AD203B41FA5}">
+                      <a16:colId xmlns:a16="http://schemas.microsoft.com/office/drawing/2014/main" val="20001"/>
+                    </a:ext>
+                  </a:extLst>
+                </a:gridCol>
+                <a:gridCol w="1889150">
+                  <a:extLst>
+                    <a:ext uri="{9D8B030D-6E8A-4147-A177-3AD203B41FA5}">
+                      <a16:colId xmlns:a16="http://schemas.microsoft.com/office/drawing/2014/main" val="20002"/>
+                    </a:ext>
+                  </a:extLst>
+                </a:gridCol>
+                <a:gridCol w="1889150">
+                  <a:extLst>
+                    <a:ext uri="{9D8B030D-6E8A-4147-A177-3AD203B41FA5}">
+                      <a16:colId xmlns:a16="http://schemas.microsoft.com/office/drawing/2014/main" val="20003"/>
+                    </a:ext>
+                  </a:extLst>
+                </a:gridCol>
+                <a:gridCol w="1889152">
+                  <a:extLst>
+                    <a:ext uri="{9D8B030D-6E8A-4147-A177-3AD203B41FA5}">
+                      <a16:colId xmlns:a16="http://schemas.microsoft.com/office/drawing/2014/main" val="20004"/>
+                    </a:ext>
+                  </a:extLst>
+                </a:gridCol>
               </a:tblGrid>
               <a:tr h="822960">
                 <a:tc>
@@ -4786,7 +5155,7 @@
                     <a:lstStyle/>
                     <a:p>
                       <a:pPr algn="ctr">
-                        <a:defRPr sz="1800" b="1">
+                        <a:defRPr sz="1400" b="1">
                           <a:solidFill>
                             <a:srgbClr val="0F172A"/>
                           </a:solidFill>
@@ -4810,7 +5179,7 @@
                     <a:lstStyle/>
                     <a:p>
                       <a:pPr algn="ctr">
-                        <a:defRPr sz="1800" b="1">
+                        <a:defRPr sz="1400" b="1">
                           <a:solidFill>
                             <a:srgbClr val="0F172A"/>
                           </a:solidFill>
@@ -4834,7 +5203,7 @@
                     <a:lstStyle/>
                     <a:p>
                       <a:pPr algn="ctr">
-                        <a:defRPr sz="1800" b="1">
+                        <a:defRPr sz="1400" b="1">
                           <a:solidFill>
                             <a:srgbClr val="0F172A"/>
                           </a:solidFill>
@@ -4858,7 +5227,7 @@
                     <a:lstStyle/>
                     <a:p>
                       <a:pPr algn="ctr">
-                        <a:defRPr sz="1800" b="1">
+                        <a:defRPr sz="1400" b="1">
                           <a:solidFill>
                             <a:srgbClr val="0F172A"/>
                           </a:solidFill>
@@ -4882,7 +5251,7 @@
                     <a:lstStyle/>
                     <a:p>
                       <a:pPr algn="ctr">
-                        <a:defRPr sz="1800" b="1">
+                        <a:defRPr sz="1400" b="1">
                           <a:solidFill>
                             <a:srgbClr val="0F172A"/>
                           </a:solidFill>
@@ -4900,6 +5269,11 @@
                     </a:solidFill>
                   </a:tcPr>
                 </a:tc>
+                <a:extLst>
+                  <a:ext uri="{0D108BD9-81ED-4DB2-BD59-A6C34878D82A}">
+                    <a16:rowId xmlns:a16="http://schemas.microsoft.com/office/drawing/2014/main" val="10000"/>
+                  </a:ext>
+                </a:extLst>
               </a:tr>
               <a:tr h="822960">
                 <a:tc>
@@ -4908,7 +5282,7 @@
                     <a:lstStyle/>
                     <a:p>
                       <a:pPr algn="ctr">
-                        <a:defRPr sz="2000" b="1">
+                        <a:defRPr sz="1600" b="1">
                           <a:solidFill>
                             <a:srgbClr val="0F172A"/>
                           </a:solidFill>
@@ -4932,7 +5306,7 @@
                     <a:lstStyle/>
                     <a:p>
                       <a:pPr algn="ctr">
-                        <a:defRPr sz="2000">
+                        <a:defRPr sz="1600">
                           <a:solidFill>
                             <a:srgbClr val="475569"/>
                           </a:solidFill>
@@ -4956,7 +5330,7 @@
                     <a:lstStyle/>
                     <a:p>
                       <a:pPr algn="ctr">
-                        <a:defRPr sz="2000">
+                        <a:defRPr sz="1600">
                           <a:solidFill>
                             <a:srgbClr val="475569"/>
                           </a:solidFill>
@@ -4980,7 +5354,7 @@
                     <a:lstStyle/>
                     <a:p>
                       <a:pPr algn="ctr">
-                        <a:defRPr sz="2000">
+                        <a:defRPr sz="1600">
                           <a:solidFill>
                             <a:srgbClr val="475569"/>
                           </a:solidFill>
@@ -5004,7 +5378,7 @@
                     <a:lstStyle/>
                     <a:p>
                       <a:pPr algn="ctr">
-                        <a:defRPr sz="2000" b="1">
+                        <a:defRPr sz="1600" b="1">
                           <a:solidFill>
                             <a:srgbClr val="0F172A"/>
                           </a:solidFill>
@@ -5022,6 +5396,11 @@
                     </a:solidFill>
                   </a:tcPr>
                 </a:tc>
+                <a:extLst>
+                  <a:ext uri="{0D108BD9-81ED-4DB2-BD59-A6C34878D82A}">
+                    <a16:rowId xmlns:a16="http://schemas.microsoft.com/office/drawing/2014/main" val="10001"/>
+                  </a:ext>
+                </a:extLst>
               </a:tr>
               <a:tr h="822960">
                 <a:tc>
@@ -5030,7 +5409,7 @@
                     <a:lstStyle/>
                     <a:p>
                       <a:pPr algn="ctr">
-                        <a:defRPr sz="2000" b="1">
+                        <a:defRPr sz="1600" b="1">
                           <a:solidFill>
                             <a:srgbClr val="0F172A"/>
                           </a:solidFill>
@@ -5054,7 +5433,7 @@
                     <a:lstStyle/>
                     <a:p>
                       <a:pPr algn="ctr">
-                        <a:defRPr sz="2000">
+                        <a:defRPr sz="1600">
                           <a:solidFill>
                             <a:srgbClr val="475569"/>
                           </a:solidFill>
@@ -5078,7 +5457,7 @@
                     <a:lstStyle/>
                     <a:p>
                       <a:pPr algn="ctr">
-                        <a:defRPr sz="2000">
+                        <a:defRPr sz="1600">
                           <a:solidFill>
                             <a:srgbClr val="475569"/>
                           </a:solidFill>
@@ -5102,7 +5481,7 @@
                     <a:lstStyle/>
                     <a:p>
                       <a:pPr algn="ctr">
-                        <a:defRPr sz="2000">
+                        <a:defRPr sz="1600">
                           <a:solidFill>
                             <a:srgbClr val="475569"/>
                           </a:solidFill>
@@ -5126,7 +5505,7 @@
                     <a:lstStyle/>
                     <a:p>
                       <a:pPr algn="ctr">
-                        <a:defRPr sz="2000" b="1">
+                        <a:defRPr sz="1600" b="1">
                           <a:solidFill>
                             <a:srgbClr val="0F172A"/>
                           </a:solidFill>
@@ -5144,6 +5523,11 @@
                     </a:solidFill>
                   </a:tcPr>
                 </a:tc>
+                <a:extLst>
+                  <a:ext uri="{0D108BD9-81ED-4DB2-BD59-A6C34878D82A}">
+                    <a16:rowId xmlns:a16="http://schemas.microsoft.com/office/drawing/2014/main" val="10002"/>
+                  </a:ext>
+                </a:extLst>
               </a:tr>
               <a:tr h="822960">
                 <a:tc>
@@ -5152,7 +5536,7 @@
                     <a:lstStyle/>
                     <a:p>
                       <a:pPr algn="ctr">
-                        <a:defRPr sz="2000" b="1">
+                        <a:defRPr sz="1600" b="1">
                           <a:solidFill>
                             <a:srgbClr val="0F172A"/>
                           </a:solidFill>
@@ -5176,7 +5560,7 @@
                     <a:lstStyle/>
                     <a:p>
                       <a:pPr algn="ctr">
-                        <a:defRPr sz="2000">
+                        <a:defRPr sz="1600">
                           <a:solidFill>
                             <a:srgbClr val="475569"/>
                           </a:solidFill>
@@ -5200,7 +5584,7 @@
                     <a:lstStyle/>
                     <a:p>
                       <a:pPr algn="ctr">
-                        <a:defRPr sz="2000">
+                        <a:defRPr sz="1600">
                           <a:solidFill>
                             <a:srgbClr val="475569"/>
                           </a:solidFill>
@@ -5224,7 +5608,7 @@
                     <a:lstStyle/>
                     <a:p>
                       <a:pPr algn="ctr">
-                        <a:defRPr sz="2000">
+                        <a:defRPr sz="1600">
                           <a:solidFill>
                             <a:srgbClr val="475569"/>
                           </a:solidFill>
@@ -5248,7 +5632,7 @@
                     <a:lstStyle/>
                     <a:p>
                       <a:pPr algn="ctr">
-                        <a:defRPr sz="2000" b="1">
+                        <a:defRPr sz="1600" b="1">
                           <a:solidFill>
                             <a:srgbClr val="0F172A"/>
                           </a:solidFill>
@@ -5266,6 +5650,11 @@
                     </a:solidFill>
                   </a:tcPr>
                 </a:tc>
+                <a:extLst>
+                  <a:ext uri="{0D108BD9-81ED-4DB2-BD59-A6C34878D82A}">
+                    <a16:rowId xmlns:a16="http://schemas.microsoft.com/office/drawing/2014/main" val="10003"/>
+                  </a:ext>
+                </a:extLst>
               </a:tr>
               <a:tr h="822960">
                 <a:tc>
@@ -5274,7 +5663,7 @@
                     <a:lstStyle/>
                     <a:p>
                       <a:pPr algn="ctr">
-                        <a:defRPr sz="2000" b="1">
+                        <a:defRPr sz="1600" b="1">
                           <a:solidFill>
                             <a:srgbClr val="0F172A"/>
                           </a:solidFill>
@@ -5298,7 +5687,7 @@
                     <a:lstStyle/>
                     <a:p>
                       <a:pPr algn="ctr">
-                        <a:defRPr sz="2000" b="1">
+                        <a:defRPr sz="1600" b="1">
                           <a:solidFill>
                             <a:srgbClr val="0F172A"/>
                           </a:solidFill>
@@ -5322,7 +5711,7 @@
                     <a:lstStyle/>
                     <a:p>
                       <a:pPr algn="ctr">
-                        <a:defRPr sz="2000" b="1">
+                        <a:defRPr sz="1600" b="1">
                           <a:solidFill>
                             <a:srgbClr val="0F172A"/>
                           </a:solidFill>
@@ -5346,7 +5735,7 @@
                     <a:lstStyle/>
                     <a:p>
                       <a:pPr algn="ctr">
-                        <a:defRPr sz="2000" b="1">
+                        <a:defRPr sz="1600" b="1">
                           <a:solidFill>
                             <a:srgbClr val="0F172A"/>
                           </a:solidFill>
@@ -5370,7 +5759,7 @@
                     <a:lstStyle/>
                     <a:p>
                       <a:pPr algn="ctr">
-                        <a:defRPr sz="2000" b="1">
+                        <a:defRPr sz="1600" b="1">
                           <a:solidFill>
                             <a:srgbClr val="0F172A"/>
                           </a:solidFill>
@@ -5388,6 +5777,11 @@
                     </a:solidFill>
                   </a:tcPr>
                 </a:tc>
+                <a:extLst>
+                  <a:ext uri="{0D108BD9-81ED-4DB2-BD59-A6C34878D82A}">
+                    <a16:rowId xmlns:a16="http://schemas.microsoft.com/office/drawing/2014/main" val="10004"/>
+                  </a:ext>
+                </a:extLst>
               </a:tr>
             </a:tbl>
           </a:graphicData>
@@ -5402,7 +5796,7 @@
 </file>
 
 <file path=ppt/slides/slide7.xml><?xml version="1.0" encoding="utf-8"?>
-<p:sld xmlns:a="http://schemas.openxmlformats.org/drawingml/2006/main" xmlns:p="http://schemas.openxmlformats.org/presentationml/2006/main" xmlns:r="http://schemas.openxmlformats.org/officeDocument/2006/relationships">
+<p:sld xmlns:a="http://schemas.openxmlformats.org/drawingml/2006/main" xmlns:r="http://schemas.openxmlformats.org/officeDocument/2006/relationships" xmlns:p="http://schemas.openxmlformats.org/presentationml/2006/main">
   <p:cSld>
     <p:bg>
       <p:bgPr>
@@ -5418,7 +5812,14 @@
         <p:cNvGrpSpPr/>
         <p:nvPr/>
       </p:nvGrpSpPr>
-      <p:grpSpPr/>
+      <p:grpSpPr>
+        <a:xfrm>
+          <a:off x="0" y="0"/>
+          <a:ext cx="0" cy="0"/>
+          <a:chOff x="0" y="0"/>
+          <a:chExt cx="0" cy="0"/>
+        </a:xfrm>
+      </p:grpSpPr>
       <p:sp>
         <p:nvSpPr>
           <p:cNvPr id="2" name="TextBox 1"/>
@@ -5486,7 +5887,7 @@
               </a:defRPr>
             </a:pPr>
             <a:r>
-              <a:t>Распределение (1)</a:t>
+              <a:t>Распределение: Шаги 1 и 2</a:t>
             </a:r>
           </a:p>
         </p:txBody>
@@ -5531,19 +5932,714 @@
           <a:lstStyle/>
           <a:p>
             <a:pPr algn="ctr"/>
-          </a:p>
-        </p:txBody>
-      </p:sp>
-      <p:sp>
-        <p:nvSpPr>
-          <p:cNvPr id="5" name="TextBox 4"/>
+            <a:endParaRPr/>
+          </a:p>
+        </p:txBody>
+      </p:sp>
+      <p:graphicFrame>
+        <p:nvGraphicFramePr>
+          <p:cNvPr id="5" name="Table 4"/>
+          <p:cNvGraphicFramePr>
+            <a:graphicFrameLocks noGrp="1"/>
+          </p:cNvGraphicFramePr>
+          <p:nvPr/>
+        </p:nvGraphicFramePr>
+        <p:xfrm>
+          <a:off x="548640" y="1645920"/>
+          <a:ext cx="5486400" cy="4114800"/>
+        </p:xfrm>
+        <a:graphic>
+          <a:graphicData uri="http://schemas.openxmlformats.org/drawingml/2006/table">
+            <a:tbl>
+              <a:tblPr firstRow="1" bandRow="1">
+                <a:tableStyleId>{5C22544A-7EE6-4342-B048-85BDC9FD1C3A}</a:tableStyleId>
+              </a:tblPr>
+              <a:tblGrid>
+                <a:gridCol w="1097280">
+                  <a:extLst>
+                    <a:ext uri="{9D8B030D-6E8A-4147-A177-3AD203B41FA5}">
+                      <a16:colId xmlns:a16="http://schemas.microsoft.com/office/drawing/2014/main" val="20000"/>
+                    </a:ext>
+                  </a:extLst>
+                </a:gridCol>
+                <a:gridCol w="1097280">
+                  <a:extLst>
+                    <a:ext uri="{9D8B030D-6E8A-4147-A177-3AD203B41FA5}">
+                      <a16:colId xmlns:a16="http://schemas.microsoft.com/office/drawing/2014/main" val="20001"/>
+                    </a:ext>
+                  </a:extLst>
+                </a:gridCol>
+                <a:gridCol w="1097280">
+                  <a:extLst>
+                    <a:ext uri="{9D8B030D-6E8A-4147-A177-3AD203B41FA5}">
+                      <a16:colId xmlns:a16="http://schemas.microsoft.com/office/drawing/2014/main" val="20002"/>
+                    </a:ext>
+                  </a:extLst>
+                </a:gridCol>
+                <a:gridCol w="1097280">
+                  <a:extLst>
+                    <a:ext uri="{9D8B030D-6E8A-4147-A177-3AD203B41FA5}">
+                      <a16:colId xmlns:a16="http://schemas.microsoft.com/office/drawing/2014/main" val="20003"/>
+                    </a:ext>
+                  </a:extLst>
+                </a:gridCol>
+                <a:gridCol w="1097280">
+                  <a:extLst>
+                    <a:ext uri="{9D8B030D-6E8A-4147-A177-3AD203B41FA5}">
+                      <a16:colId xmlns:a16="http://schemas.microsoft.com/office/drawing/2014/main" val="20004"/>
+                    </a:ext>
+                  </a:extLst>
+                </a:gridCol>
+              </a:tblGrid>
+              <a:tr h="822960">
+                <a:tc>
+                  <a:txBody>
+                    <a:bodyPr/>
+                    <a:lstStyle/>
+                    <a:p>
+                      <a:pPr algn="ctr">
+                        <a:defRPr sz="1400" b="1">
+                          <a:solidFill>
+                            <a:srgbClr val="0F172A"/>
+                          </a:solidFill>
+                          <a:latin typeface="Arial"/>
+                        </a:defRPr>
+                      </a:pPr>
+                      <a:r>
+                        <a:t>Пост. \ Потр.</a:t>
+                      </a:r>
+                    </a:p>
+                  </a:txBody>
+                  <a:tcPr>
+                    <a:solidFill>
+                      <a:srgbClr val="EFF6FF"/>
+                    </a:solidFill>
+                  </a:tcPr>
+                </a:tc>
+                <a:tc>
+                  <a:txBody>
+                    <a:bodyPr/>
+                    <a:lstStyle/>
+                    <a:p>
+                      <a:pPr algn="ctr">
+                        <a:defRPr sz="1400" b="1">
+                          <a:solidFill>
+                            <a:srgbClr val="0F172A"/>
+                          </a:solidFill>
+                          <a:latin typeface="Arial"/>
+                        </a:defRPr>
+                      </a:pPr>
+                      <a:r>
+                        <a:t>B1</a:t>
+                      </a:r>
+                    </a:p>
+                  </a:txBody>
+                  <a:tcPr>
+                    <a:solidFill>
+                      <a:srgbClr val="EFF6FF"/>
+                    </a:solidFill>
+                  </a:tcPr>
+                </a:tc>
+                <a:tc>
+                  <a:txBody>
+                    <a:bodyPr/>
+                    <a:lstStyle/>
+                    <a:p>
+                      <a:pPr algn="ctr">
+                        <a:defRPr sz="1400" b="1">
+                          <a:solidFill>
+                            <a:srgbClr val="0F172A"/>
+                          </a:solidFill>
+                          <a:latin typeface="Arial"/>
+                        </a:defRPr>
+                      </a:pPr>
+                      <a:r>
+                        <a:t>B2</a:t>
+                      </a:r>
+                    </a:p>
+                  </a:txBody>
+                  <a:tcPr>
+                    <a:solidFill>
+                      <a:srgbClr val="EFF6FF"/>
+                    </a:solidFill>
+                  </a:tcPr>
+                </a:tc>
+                <a:tc>
+                  <a:txBody>
+                    <a:bodyPr/>
+                    <a:lstStyle/>
+                    <a:p>
+                      <a:pPr algn="ctr">
+                        <a:defRPr sz="1400" b="1">
+                          <a:solidFill>
+                            <a:srgbClr val="0F172A"/>
+                          </a:solidFill>
+                          <a:latin typeface="Arial"/>
+                        </a:defRPr>
+                      </a:pPr>
+                      <a:r>
+                        <a:t>B3</a:t>
+                      </a:r>
+                    </a:p>
+                  </a:txBody>
+                  <a:tcPr>
+                    <a:solidFill>
+                      <a:srgbClr val="EFF6FF"/>
+                    </a:solidFill>
+                  </a:tcPr>
+                </a:tc>
+                <a:tc>
+                  <a:txBody>
+                    <a:bodyPr/>
+                    <a:lstStyle/>
+                    <a:p>
+                      <a:pPr algn="ctr">
+                        <a:defRPr sz="1400" b="1">
+                          <a:solidFill>
+                            <a:srgbClr val="0F172A"/>
+                          </a:solidFill>
+                          <a:latin typeface="Arial"/>
+                        </a:defRPr>
+                      </a:pPr>
+                      <a:r>
+                        <a:t>Запасы A</a:t>
+                      </a:r>
+                    </a:p>
+                  </a:txBody>
+                  <a:tcPr>
+                    <a:solidFill>
+                      <a:srgbClr val="EFF6FF"/>
+                    </a:solidFill>
+                  </a:tcPr>
+                </a:tc>
+                <a:extLst>
+                  <a:ext uri="{0D108BD9-81ED-4DB2-BD59-A6C34878D82A}">
+                    <a16:rowId xmlns:a16="http://schemas.microsoft.com/office/drawing/2014/main" val="10000"/>
+                  </a:ext>
+                </a:extLst>
+              </a:tr>
+              <a:tr h="822960">
+                <a:tc>
+                  <a:txBody>
+                    <a:bodyPr/>
+                    <a:lstStyle/>
+                    <a:p>
+                      <a:pPr algn="ctr">
+                        <a:defRPr sz="1600" b="1">
+                          <a:solidFill>
+                            <a:srgbClr val="0F172A"/>
+                          </a:solidFill>
+                          <a:latin typeface="Calibri"/>
+                        </a:defRPr>
+                      </a:pPr>
+                      <a:r>
+                        <a:t>A1</a:t>
+                      </a:r>
+                    </a:p>
+                  </a:txBody>
+                  <a:tcPr>
+                    <a:solidFill>
+                      <a:srgbClr val="FFFFFF"/>
+                    </a:solidFill>
+                  </a:tcPr>
+                </a:tc>
+                <a:tc>
+                  <a:txBody>
+                    <a:bodyPr/>
+                    <a:lstStyle/>
+                    <a:p>
+                      <a:pPr algn="ctr">
+                        <a:defRPr sz="1600" b="1">
+                          <a:solidFill>
+                            <a:srgbClr val="2563EB"/>
+                          </a:solidFill>
+                          <a:latin typeface="Calibri"/>
+                        </a:defRPr>
+                      </a:pPr>
+                      <a:r>
+                        <a:t>60</a:t>
+                      </a:r>
+                    </a:p>
+                  </a:txBody>
+                  <a:tcPr>
+                    <a:solidFill>
+                      <a:srgbClr val="FFFFFF"/>
+                    </a:solidFill>
+                  </a:tcPr>
+                </a:tc>
+                <a:tc>
+                  <a:txBody>
+                    <a:bodyPr/>
+                    <a:lstStyle/>
+                    <a:p>
+                      <a:pPr algn="ctr">
+                        <a:defRPr sz="1600">
+                          <a:solidFill>
+                            <a:srgbClr val="475569"/>
+                          </a:solidFill>
+                          <a:latin typeface="Calibri"/>
+                        </a:defRPr>
+                      </a:pPr>
+                      <a:r>
+                        <a:t>—</a:t>
+                      </a:r>
+                    </a:p>
+                  </a:txBody>
+                  <a:tcPr>
+                    <a:solidFill>
+                      <a:srgbClr val="FFFFFF"/>
+                    </a:solidFill>
+                  </a:tcPr>
+                </a:tc>
+                <a:tc>
+                  <a:txBody>
+                    <a:bodyPr/>
+                    <a:lstStyle/>
+                    <a:p>
+                      <a:pPr algn="ctr">
+                        <a:defRPr sz="1600">
+                          <a:solidFill>
+                            <a:srgbClr val="475569"/>
+                          </a:solidFill>
+                          <a:latin typeface="Calibri"/>
+                        </a:defRPr>
+                      </a:pPr>
+                      <a:r>
+                        <a:t>—</a:t>
+                      </a:r>
+                    </a:p>
+                  </a:txBody>
+                  <a:tcPr>
+                    <a:solidFill>
+                      <a:srgbClr val="FFFFFF"/>
+                    </a:solidFill>
+                  </a:tcPr>
+                </a:tc>
+                <a:tc>
+                  <a:txBody>
+                    <a:bodyPr/>
+                    <a:lstStyle/>
+                    <a:p>
+                      <a:pPr algn="ctr">
+                        <a:defRPr sz="1600" b="1">
+                          <a:solidFill>
+                            <a:srgbClr val="0F172A"/>
+                          </a:solidFill>
+                          <a:latin typeface="Calibri"/>
+                        </a:defRPr>
+                      </a:pPr>
+                      <a:r>
+                        <a:t>60 → 0</a:t>
+                      </a:r>
+                    </a:p>
+                  </a:txBody>
+                  <a:tcPr>
+                    <a:solidFill>
+                      <a:srgbClr val="F8FAFC"/>
+                    </a:solidFill>
+                  </a:tcPr>
+                </a:tc>
+                <a:extLst>
+                  <a:ext uri="{0D108BD9-81ED-4DB2-BD59-A6C34878D82A}">
+                    <a16:rowId xmlns:a16="http://schemas.microsoft.com/office/drawing/2014/main" val="10001"/>
+                  </a:ext>
+                </a:extLst>
+              </a:tr>
+              <a:tr h="822960">
+                <a:tc>
+                  <a:txBody>
+                    <a:bodyPr/>
+                    <a:lstStyle/>
+                    <a:p>
+                      <a:pPr algn="ctr">
+                        <a:defRPr sz="1600" b="1">
+                          <a:solidFill>
+                            <a:srgbClr val="0F172A"/>
+                          </a:solidFill>
+                          <a:latin typeface="Calibri"/>
+                        </a:defRPr>
+                      </a:pPr>
+                      <a:r>
+                        <a:t>A2</a:t>
+                      </a:r>
+                    </a:p>
+                  </a:txBody>
+                  <a:tcPr>
+                    <a:solidFill>
+                      <a:srgbClr val="FFFFFF"/>
+                    </a:solidFill>
+                  </a:tcPr>
+                </a:tc>
+                <a:tc>
+                  <a:txBody>
+                    <a:bodyPr/>
+                    <a:lstStyle/>
+                    <a:p>
+                      <a:pPr algn="ctr">
+                        <a:defRPr sz="1600">
+                          <a:solidFill>
+                            <a:srgbClr val="475569"/>
+                          </a:solidFill>
+                          <a:latin typeface="Calibri"/>
+                        </a:defRPr>
+                      </a:pPr>
+                      <a:r>
+                        <a:t>—</a:t>
+                      </a:r>
+                    </a:p>
+                  </a:txBody>
+                  <a:tcPr>
+                    <a:solidFill>
+                      <a:srgbClr val="FFFFFF"/>
+                    </a:solidFill>
+                  </a:tcPr>
+                </a:tc>
+                <a:tc>
+                  <a:txBody>
+                    <a:bodyPr/>
+                    <a:lstStyle/>
+                    <a:p>
+                      <a:pPr algn="ctr">
+                        <a:defRPr sz="1600" b="1">
+                          <a:solidFill>
+                            <a:srgbClr val="2563EB"/>
+                          </a:solidFill>
+                          <a:latin typeface="Calibri"/>
+                        </a:defRPr>
+                      </a:pPr>
+                      <a:r>
+                        <a:t>80</a:t>
+                      </a:r>
+                    </a:p>
+                  </a:txBody>
+                  <a:tcPr>
+                    <a:solidFill>
+                      <a:srgbClr val="FFFFFF"/>
+                    </a:solidFill>
+                  </a:tcPr>
+                </a:tc>
+                <a:tc>
+                  <a:txBody>
+                    <a:bodyPr/>
+                    <a:lstStyle/>
+                    <a:p>
+                      <a:pPr algn="ctr">
+                        <a:defRPr sz="1600">
+                          <a:solidFill>
+                            <a:srgbClr val="475569"/>
+                          </a:solidFill>
+                          <a:latin typeface="Calibri"/>
+                        </a:defRPr>
+                      </a:pPr>
+                      <a:r>
+                        <a:t>—</a:t>
+                      </a:r>
+                    </a:p>
+                  </a:txBody>
+                  <a:tcPr>
+                    <a:solidFill>
+                      <a:srgbClr val="FFFFFF"/>
+                    </a:solidFill>
+                  </a:tcPr>
+                </a:tc>
+                <a:tc>
+                  <a:txBody>
+                    <a:bodyPr/>
+                    <a:lstStyle/>
+                    <a:p>
+                      <a:pPr algn="ctr">
+                        <a:defRPr sz="1600" b="1">
+                          <a:solidFill>
+                            <a:srgbClr val="0F172A"/>
+                          </a:solidFill>
+                          <a:latin typeface="Calibri"/>
+                        </a:defRPr>
+                      </a:pPr>
+                      <a:r>
+                        <a:t>80 → 0</a:t>
+                      </a:r>
+                    </a:p>
+                  </a:txBody>
+                  <a:tcPr>
+                    <a:solidFill>
+                      <a:srgbClr val="F8FAFC"/>
+                    </a:solidFill>
+                  </a:tcPr>
+                </a:tc>
+                <a:extLst>
+                  <a:ext uri="{0D108BD9-81ED-4DB2-BD59-A6C34878D82A}">
+                    <a16:rowId xmlns:a16="http://schemas.microsoft.com/office/drawing/2014/main" val="10002"/>
+                  </a:ext>
+                </a:extLst>
+              </a:tr>
+              <a:tr h="822960">
+                <a:tc>
+                  <a:txBody>
+                    <a:bodyPr/>
+                    <a:lstStyle/>
+                    <a:p>
+                      <a:pPr algn="ctr">
+                        <a:defRPr sz="1600" b="1">
+                          <a:solidFill>
+                            <a:srgbClr val="0F172A"/>
+                          </a:solidFill>
+                          <a:latin typeface="Calibri"/>
+                        </a:defRPr>
+                      </a:pPr>
+                      <a:r>
+                        <a:t>A3</a:t>
+                      </a:r>
+                    </a:p>
+                  </a:txBody>
+                  <a:tcPr>
+                    <a:solidFill>
+                      <a:srgbClr val="FFFFFF"/>
+                    </a:solidFill>
+                  </a:tcPr>
+                </a:tc>
+                <a:tc>
+                  <a:txBody>
+                    <a:bodyPr/>
+                    <a:lstStyle/>
+                    <a:p>
+                      <a:pPr algn="ctr">
+                        <a:defRPr sz="1600">
+                          <a:solidFill>
+                            <a:srgbClr val="475569"/>
+                          </a:solidFill>
+                          <a:latin typeface="Calibri"/>
+                        </a:defRPr>
+                      </a:pPr>
+                      <a:r>
+                        <a:t>—</a:t>
+                      </a:r>
+                    </a:p>
+                  </a:txBody>
+                  <a:tcPr>
+                    <a:solidFill>
+                      <a:srgbClr val="FFFFFF"/>
+                    </a:solidFill>
+                  </a:tcPr>
+                </a:tc>
+                <a:tc>
+                  <a:txBody>
+                    <a:bodyPr/>
+                    <a:lstStyle/>
+                    <a:p>
+                      <a:pPr algn="ctr">
+                        <a:defRPr sz="1600">
+                          <a:solidFill>
+                            <a:srgbClr val="475569"/>
+                          </a:solidFill>
+                          <a:latin typeface="Calibri"/>
+                        </a:defRPr>
+                      </a:pPr>
+                      <a:r>
+                        <a:t>—</a:t>
+                      </a:r>
+                    </a:p>
+                  </a:txBody>
+                  <a:tcPr>
+                    <a:solidFill>
+                      <a:srgbClr val="FFFFFF"/>
+                    </a:solidFill>
+                  </a:tcPr>
+                </a:tc>
+                <a:tc>
+                  <a:txBody>
+                    <a:bodyPr/>
+                    <a:lstStyle/>
+                    <a:p>
+                      <a:pPr algn="ctr">
+                        <a:defRPr sz="1600">
+                          <a:solidFill>
+                            <a:srgbClr val="475569"/>
+                          </a:solidFill>
+                          <a:latin typeface="Calibri"/>
+                        </a:defRPr>
+                      </a:pPr>
+                      <a:r>
+                        <a:t>—</a:t>
+                      </a:r>
+                    </a:p>
+                  </a:txBody>
+                  <a:tcPr>
+                    <a:solidFill>
+                      <a:srgbClr val="FFFFFF"/>
+                    </a:solidFill>
+                  </a:tcPr>
+                </a:tc>
+                <a:tc>
+                  <a:txBody>
+                    <a:bodyPr/>
+                    <a:lstStyle/>
+                    <a:p>
+                      <a:pPr algn="ctr">
+                        <a:defRPr sz="1600" b="1">
+                          <a:solidFill>
+                            <a:srgbClr val="0F172A"/>
+                          </a:solidFill>
+                          <a:latin typeface="Calibri"/>
+                        </a:defRPr>
+                      </a:pPr>
+                      <a:r>
+                        <a:t>100</a:t>
+                      </a:r>
+                    </a:p>
+                  </a:txBody>
+                  <a:tcPr>
+                    <a:solidFill>
+                      <a:srgbClr val="F8FAFC"/>
+                    </a:solidFill>
+                  </a:tcPr>
+                </a:tc>
+                <a:extLst>
+                  <a:ext uri="{0D108BD9-81ED-4DB2-BD59-A6C34878D82A}">
+                    <a16:rowId xmlns:a16="http://schemas.microsoft.com/office/drawing/2014/main" val="10003"/>
+                  </a:ext>
+                </a:extLst>
+              </a:tr>
+              <a:tr h="822960">
+                <a:tc>
+                  <a:txBody>
+                    <a:bodyPr/>
+                    <a:lstStyle/>
+                    <a:p>
+                      <a:pPr algn="ctr">
+                        <a:defRPr sz="1600" b="1">
+                          <a:solidFill>
+                            <a:srgbClr val="0F172A"/>
+                          </a:solidFill>
+                          <a:latin typeface="Calibri"/>
+                        </a:defRPr>
+                      </a:pPr>
+                      <a:r>
+                        <a:t>Спрос B</a:t>
+                      </a:r>
+                    </a:p>
+                  </a:txBody>
+                  <a:tcPr>
+                    <a:solidFill>
+                      <a:srgbClr val="F8FAFC"/>
+                    </a:solidFill>
+                  </a:tcPr>
+                </a:tc>
+                <a:tc>
+                  <a:txBody>
+                    <a:bodyPr/>
+                    <a:lstStyle/>
+                    <a:p>
+                      <a:pPr algn="ctr">
+                        <a:defRPr sz="1600" b="1">
+                          <a:solidFill>
+                            <a:srgbClr val="0F172A"/>
+                          </a:solidFill>
+                          <a:latin typeface="Calibri"/>
+                        </a:defRPr>
+                      </a:pPr>
+                      <a:r>
+                        <a:t>70 → 10</a:t>
+                      </a:r>
+                    </a:p>
+                  </a:txBody>
+                  <a:tcPr>
+                    <a:solidFill>
+                      <a:srgbClr val="F8FAFC"/>
+                    </a:solidFill>
+                  </a:tcPr>
+                </a:tc>
+                <a:tc>
+                  <a:txBody>
+                    <a:bodyPr/>
+                    <a:lstStyle/>
+                    <a:p>
+                      <a:pPr algn="ctr">
+                        <a:defRPr sz="1600" b="1">
+                          <a:solidFill>
+                            <a:srgbClr val="0F172A"/>
+                          </a:solidFill>
+                          <a:latin typeface="Calibri"/>
+                        </a:defRPr>
+                      </a:pPr>
+                      <a:r>
+                        <a:t>90 → 10</a:t>
+                      </a:r>
+                    </a:p>
+                  </a:txBody>
+                  <a:tcPr>
+                    <a:solidFill>
+                      <a:srgbClr val="F8FAFC"/>
+                    </a:solidFill>
+                  </a:tcPr>
+                </a:tc>
+                <a:tc>
+                  <a:txBody>
+                    <a:bodyPr/>
+                    <a:lstStyle/>
+                    <a:p>
+                      <a:pPr algn="ctr">
+                        <a:defRPr sz="1600" b="1">
+                          <a:solidFill>
+                            <a:srgbClr val="0F172A"/>
+                          </a:solidFill>
+                          <a:latin typeface="Calibri"/>
+                        </a:defRPr>
+                      </a:pPr>
+                      <a:r>
+                        <a:t>80</a:t>
+                      </a:r>
+                    </a:p>
+                  </a:txBody>
+                  <a:tcPr>
+                    <a:solidFill>
+                      <a:srgbClr val="F8FAFC"/>
+                    </a:solidFill>
+                  </a:tcPr>
+                </a:tc>
+                <a:tc>
+                  <a:txBody>
+                    <a:bodyPr/>
+                    <a:lstStyle/>
+                    <a:p>
+                      <a:pPr algn="ctr">
+                        <a:defRPr sz="1600" b="1">
+                          <a:solidFill>
+                            <a:srgbClr val="0F172A"/>
+                          </a:solidFill>
+                          <a:latin typeface="Calibri"/>
+                        </a:defRPr>
+                      </a:pPr>
+                      <a:r>
+                        <a:t>240</a:t>
+                      </a:r>
+                    </a:p>
+                  </a:txBody>
+                  <a:tcPr>
+                    <a:solidFill>
+                      <a:srgbClr val="F8FAFC"/>
+                    </a:solidFill>
+                  </a:tcPr>
+                </a:tc>
+                <a:extLst>
+                  <a:ext uri="{0D108BD9-81ED-4DB2-BD59-A6C34878D82A}">
+                    <a16:rowId xmlns:a16="http://schemas.microsoft.com/office/drawing/2014/main" val="10004"/>
+                  </a:ext>
+                </a:extLst>
+              </a:tr>
+            </a:tbl>
+          </a:graphicData>
+        </a:graphic>
+      </p:graphicFrame>
+      <p:sp>
+        <p:nvSpPr>
+          <p:cNvPr id="6" name="TextBox 5"/>
           <p:cNvSpPr txBox="1"/>
           <p:nvPr/>
         </p:nvSpPr>
         <p:spPr>
           <a:xfrm>
-            <a:off x="548640" y="1645920"/>
-            <a:ext cx="11094415" cy="4572000"/>
+            <a:off x="6217920" y="1645920"/>
+            <a:ext cx="5303520" cy="4114800"/>
           </a:xfrm>
           <a:prstGeom prst="rect">
             <a:avLst/>
@@ -5557,7 +6653,10 @@
           <a:lstStyle/>
           <a:p>
             <a:pPr>
-              <a:defRPr sz="2400" b="1">
+              <a:spcAft>
+                <a:spcPts val="400"/>
+              </a:spcAft>
+              <a:defRPr sz="2200" b="1">
                 <a:solidFill>
                   <a:srgbClr val="2563EB"/>
                 </a:solidFill>
@@ -5565,31 +6664,68 @@
               </a:defRPr>
             </a:pPr>
             <a:r>
-              <a:t>Шаг 1. Клетка (A2, B2) с тарифом 1:</a:t>
+              <a:t>Шаг 1. Распределение в клетку (A2, B2) с тарифом 1</a:t>
             </a:r>
           </a:p>
           <a:p>
             <a:pPr>
-              <a:defRPr sz="2200">
+              <a:spcAft>
+                <a:spcPts val="400"/>
+              </a:spcAft>
+              <a:defRPr sz="2000" b="1"/>
+            </a:pPr>
+            <a:r>
+              <a:rPr sz="2000" b="1">
                 <a:solidFill>
                   <a:srgbClr val="0F172A"/>
+                </a:solidFill>
+                <a:latin typeface="Arial"/>
+              </a:rPr>
+              <a:t>x</a:t>
+            </a:r>
+            <a:r>
+              <a:rPr sz="1400" b="1" baseline="-25000">
+                <a:solidFill>
+                  <a:srgbClr val="0F172A"/>
+                </a:solidFill>
+                <a:latin typeface="Arial"/>
+              </a:rPr>
+              <a:t>22</a:t>
+            </a:r>
+            <a:r>
+              <a:rPr sz="2000" b="1">
+                <a:solidFill>
+                  <a:srgbClr val="0F172A"/>
+                </a:solidFill>
+                <a:latin typeface="Arial"/>
+              </a:rPr>
+              <a:t> = min(80, 90) = 80</a:t>
+            </a:r>
+          </a:p>
+          <a:p>
+            <a:pPr>
+              <a:spcAft>
+                <a:spcPts val="1400"/>
+              </a:spcAft>
+              <a:defRPr sz="1800">
+                <a:solidFill>
+                  <a:srgbClr val="475569"/>
                 </a:solidFill>
                 <a:latin typeface="Calibri"/>
               </a:defRPr>
             </a:pPr>
             <a:r>
-              <a:t>x_22 = min(80, 90) = 80.</a:t>
+              <a:t>Запасы поставщика A2 исчерпаны. Спрос B2 снижается до 10.</a:t>
             </a:r>
             <a:br/>
-            <a:r>
-              <a:t>Поставщик A2 исчерпан (строка 2 выбывает). Спрос B2 сокращается до 10.</a:t>
-            </a:r>
-            <a:br/>
-            <a:br/>
+            <a:endParaRPr/>
           </a:p>
           <a:p>
             <a:pPr>
-              <a:defRPr sz="2400" b="1">
+              <a:spcAft>
+                <a:spcPts val="400"/>
+              </a:spcAft>
+              <a:defRPr sz="2200" b="1">
                 <a:solidFill>
                   <a:srgbClr val="2563EB"/>
                 </a:solidFill>
@@ -5597,24 +6733,55 @@
               </a:defRPr>
             </a:pPr>
             <a:r>
-              <a:t>Шаг 2. Клетка (A1, B1) с тарифом 2:</a:t>
+              <a:t>Шаг 2. Распределение в клетку (A1, B1) с тарифом 2</a:t>
             </a:r>
           </a:p>
           <a:p>
             <a:pPr>
-              <a:defRPr sz="2200">
+              <a:spcAft>
+                <a:spcPts val="400"/>
+              </a:spcAft>
+              <a:defRPr sz="2000" b="1"/>
+            </a:pPr>
+            <a:r>
+              <a:rPr sz="2000" b="1">
                 <a:solidFill>
                   <a:srgbClr val="0F172A"/>
+                </a:solidFill>
+                <a:latin typeface="Arial"/>
+              </a:rPr>
+              <a:t>x</a:t>
+            </a:r>
+            <a:r>
+              <a:rPr sz="1400" b="1" baseline="-25000">
+                <a:solidFill>
+                  <a:srgbClr val="0F172A"/>
+                </a:solidFill>
+                <a:latin typeface="Arial"/>
+              </a:rPr>
+              <a:t>11</a:t>
+            </a:r>
+            <a:r>
+              <a:rPr sz="2000" b="1">
+                <a:solidFill>
+                  <a:srgbClr val="0F172A"/>
+                </a:solidFill>
+                <a:latin typeface="Arial"/>
+              </a:rPr>
+              <a:t> = min(60, 70) = 60</a:t>
+            </a:r>
+          </a:p>
+          <a:p>
+            <a:pPr>
+              <a:defRPr sz="1800">
+                <a:solidFill>
+                  <a:srgbClr val="475569"/>
                 </a:solidFill>
                 <a:latin typeface="Calibri"/>
               </a:defRPr>
             </a:pPr>
             <a:r>
-              <a:t>x_11 = min(60, 70) = 60.</a:t>
-            </a:r>
-            <a:br/>
-            <a:r>
-              <a:t>Поставщик A1 исчерпан (строка 1 выбывает). Спрос B1 сокращается до 10.</a:t>
+              <a:t>Запасы поставщика A1 исчерпаны. Спрос B1 снижается до 10.</a:t>
             </a:r>
           </a:p>
         </p:txBody>
@@ -5628,7 +6795,7 @@
 </file>
 
 <file path=ppt/slides/slide8.xml><?xml version="1.0" encoding="utf-8"?>
-<p:sld xmlns:a="http://schemas.openxmlformats.org/drawingml/2006/main" xmlns:p="http://schemas.openxmlformats.org/presentationml/2006/main" xmlns:r="http://schemas.openxmlformats.org/officeDocument/2006/relationships">
+<p:sld xmlns:a="http://schemas.openxmlformats.org/drawingml/2006/main" xmlns:r="http://schemas.openxmlformats.org/officeDocument/2006/relationships" xmlns:p="http://schemas.openxmlformats.org/presentationml/2006/main">
   <p:cSld>
     <p:bg>
       <p:bgPr>
@@ -5644,7 +6811,14 @@
         <p:cNvGrpSpPr/>
         <p:nvPr/>
       </p:nvGrpSpPr>
-      <p:grpSpPr/>
+      <p:grpSpPr>
+        <a:xfrm>
+          <a:off x="0" y="0"/>
+          <a:ext cx="0" cy="0"/>
+          <a:chOff x="0" y="0"/>
+          <a:chExt cx="0" cy="0"/>
+        </a:xfrm>
+      </p:grpSpPr>
       <p:sp>
         <p:nvSpPr>
           <p:cNvPr id="2" name="TextBox 1"/>
@@ -5712,7 +6886,7 @@
               </a:defRPr>
             </a:pPr>
             <a:r>
-              <a:t>Распределение (2)</a:t>
+              <a:t>Распределение: Шаги 3, 4 и 5</a:t>
             </a:r>
           </a:p>
         </p:txBody>
@@ -5757,19 +6931,714 @@
           <a:lstStyle/>
           <a:p>
             <a:pPr algn="ctr"/>
-          </a:p>
-        </p:txBody>
-      </p:sp>
-      <p:sp>
-        <p:nvSpPr>
-          <p:cNvPr id="5" name="TextBox 4"/>
+            <a:endParaRPr/>
+          </a:p>
+        </p:txBody>
+      </p:sp>
+      <p:graphicFrame>
+        <p:nvGraphicFramePr>
+          <p:cNvPr id="5" name="Table 4"/>
+          <p:cNvGraphicFramePr>
+            <a:graphicFrameLocks noGrp="1"/>
+          </p:cNvGraphicFramePr>
+          <p:nvPr/>
+        </p:nvGraphicFramePr>
+        <p:xfrm>
+          <a:off x="548640" y="1645920"/>
+          <a:ext cx="5486400" cy="4114800"/>
+        </p:xfrm>
+        <a:graphic>
+          <a:graphicData uri="http://schemas.openxmlformats.org/drawingml/2006/table">
+            <a:tbl>
+              <a:tblPr firstRow="1" bandRow="1">
+                <a:tableStyleId>{5C22544A-7EE6-4342-B048-85BDC9FD1C3A}</a:tableStyleId>
+              </a:tblPr>
+              <a:tblGrid>
+                <a:gridCol w="1097280">
+                  <a:extLst>
+                    <a:ext uri="{9D8B030D-6E8A-4147-A177-3AD203B41FA5}">
+                      <a16:colId xmlns:a16="http://schemas.microsoft.com/office/drawing/2014/main" val="20000"/>
+                    </a:ext>
+                  </a:extLst>
+                </a:gridCol>
+                <a:gridCol w="1097280">
+                  <a:extLst>
+                    <a:ext uri="{9D8B030D-6E8A-4147-A177-3AD203B41FA5}">
+                      <a16:colId xmlns:a16="http://schemas.microsoft.com/office/drawing/2014/main" val="20001"/>
+                    </a:ext>
+                  </a:extLst>
+                </a:gridCol>
+                <a:gridCol w="1097280">
+                  <a:extLst>
+                    <a:ext uri="{9D8B030D-6E8A-4147-A177-3AD203B41FA5}">
+                      <a16:colId xmlns:a16="http://schemas.microsoft.com/office/drawing/2014/main" val="20002"/>
+                    </a:ext>
+                  </a:extLst>
+                </a:gridCol>
+                <a:gridCol w="1097280">
+                  <a:extLst>
+                    <a:ext uri="{9D8B030D-6E8A-4147-A177-3AD203B41FA5}">
+                      <a16:colId xmlns:a16="http://schemas.microsoft.com/office/drawing/2014/main" val="20003"/>
+                    </a:ext>
+                  </a:extLst>
+                </a:gridCol>
+                <a:gridCol w="1097280">
+                  <a:extLst>
+                    <a:ext uri="{9D8B030D-6E8A-4147-A177-3AD203B41FA5}">
+                      <a16:colId xmlns:a16="http://schemas.microsoft.com/office/drawing/2014/main" val="20004"/>
+                    </a:ext>
+                  </a:extLst>
+                </a:gridCol>
+              </a:tblGrid>
+              <a:tr h="822960">
+                <a:tc>
+                  <a:txBody>
+                    <a:bodyPr/>
+                    <a:lstStyle/>
+                    <a:p>
+                      <a:pPr algn="ctr">
+                        <a:defRPr sz="1400" b="1">
+                          <a:solidFill>
+                            <a:srgbClr val="0F172A"/>
+                          </a:solidFill>
+                          <a:latin typeface="Arial"/>
+                        </a:defRPr>
+                      </a:pPr>
+                      <a:r>
+                        <a:t>Пост. \ Потр.</a:t>
+                      </a:r>
+                    </a:p>
+                  </a:txBody>
+                  <a:tcPr>
+                    <a:solidFill>
+                      <a:srgbClr val="EFF6FF"/>
+                    </a:solidFill>
+                  </a:tcPr>
+                </a:tc>
+                <a:tc>
+                  <a:txBody>
+                    <a:bodyPr/>
+                    <a:lstStyle/>
+                    <a:p>
+                      <a:pPr algn="ctr">
+                        <a:defRPr sz="1400" b="1">
+                          <a:solidFill>
+                            <a:srgbClr val="0F172A"/>
+                          </a:solidFill>
+                          <a:latin typeface="Arial"/>
+                        </a:defRPr>
+                      </a:pPr>
+                      <a:r>
+                        <a:t>B1</a:t>
+                      </a:r>
+                    </a:p>
+                  </a:txBody>
+                  <a:tcPr>
+                    <a:solidFill>
+                      <a:srgbClr val="EFF6FF"/>
+                    </a:solidFill>
+                  </a:tcPr>
+                </a:tc>
+                <a:tc>
+                  <a:txBody>
+                    <a:bodyPr/>
+                    <a:lstStyle/>
+                    <a:p>
+                      <a:pPr algn="ctr">
+                        <a:defRPr sz="1400" b="1">
+                          <a:solidFill>
+                            <a:srgbClr val="0F172A"/>
+                          </a:solidFill>
+                          <a:latin typeface="Arial"/>
+                        </a:defRPr>
+                      </a:pPr>
+                      <a:r>
+                        <a:t>B2</a:t>
+                      </a:r>
+                    </a:p>
+                  </a:txBody>
+                  <a:tcPr>
+                    <a:solidFill>
+                      <a:srgbClr val="EFF6FF"/>
+                    </a:solidFill>
+                  </a:tcPr>
+                </a:tc>
+                <a:tc>
+                  <a:txBody>
+                    <a:bodyPr/>
+                    <a:lstStyle/>
+                    <a:p>
+                      <a:pPr algn="ctr">
+                        <a:defRPr sz="1400" b="1">
+                          <a:solidFill>
+                            <a:srgbClr val="0F172A"/>
+                          </a:solidFill>
+                          <a:latin typeface="Arial"/>
+                        </a:defRPr>
+                      </a:pPr>
+                      <a:r>
+                        <a:t>B3</a:t>
+                      </a:r>
+                    </a:p>
+                  </a:txBody>
+                  <a:tcPr>
+                    <a:solidFill>
+                      <a:srgbClr val="EFF6FF"/>
+                    </a:solidFill>
+                  </a:tcPr>
+                </a:tc>
+                <a:tc>
+                  <a:txBody>
+                    <a:bodyPr/>
+                    <a:lstStyle/>
+                    <a:p>
+                      <a:pPr algn="ctr">
+                        <a:defRPr sz="1400" b="1">
+                          <a:solidFill>
+                            <a:srgbClr val="0F172A"/>
+                          </a:solidFill>
+                          <a:latin typeface="Arial"/>
+                        </a:defRPr>
+                      </a:pPr>
+                      <a:r>
+                        <a:t>Запасы A</a:t>
+                      </a:r>
+                    </a:p>
+                  </a:txBody>
+                  <a:tcPr>
+                    <a:solidFill>
+                      <a:srgbClr val="EFF6FF"/>
+                    </a:solidFill>
+                  </a:tcPr>
+                </a:tc>
+                <a:extLst>
+                  <a:ext uri="{0D108BD9-81ED-4DB2-BD59-A6C34878D82A}">
+                    <a16:rowId xmlns:a16="http://schemas.microsoft.com/office/drawing/2014/main" val="10000"/>
+                  </a:ext>
+                </a:extLst>
+              </a:tr>
+              <a:tr h="822960">
+                <a:tc>
+                  <a:txBody>
+                    <a:bodyPr/>
+                    <a:lstStyle/>
+                    <a:p>
+                      <a:pPr algn="ctr">
+                        <a:defRPr sz="1600" b="1">
+                          <a:solidFill>
+                            <a:srgbClr val="0F172A"/>
+                          </a:solidFill>
+                          <a:latin typeface="Calibri"/>
+                        </a:defRPr>
+                      </a:pPr>
+                      <a:r>
+                        <a:t>A1</a:t>
+                      </a:r>
+                    </a:p>
+                  </a:txBody>
+                  <a:tcPr>
+                    <a:solidFill>
+                      <a:srgbClr val="FFFFFF"/>
+                    </a:solidFill>
+                  </a:tcPr>
+                </a:tc>
+                <a:tc>
+                  <a:txBody>
+                    <a:bodyPr/>
+                    <a:lstStyle/>
+                    <a:p>
+                      <a:pPr algn="ctr">
+                        <a:defRPr sz="1600" b="1">
+                          <a:solidFill>
+                            <a:srgbClr val="2563EB"/>
+                          </a:solidFill>
+                          <a:latin typeface="Calibri"/>
+                        </a:defRPr>
+                      </a:pPr>
+                      <a:r>
+                        <a:t>60</a:t>
+                      </a:r>
+                    </a:p>
+                  </a:txBody>
+                  <a:tcPr>
+                    <a:solidFill>
+                      <a:srgbClr val="FFFFFF"/>
+                    </a:solidFill>
+                  </a:tcPr>
+                </a:tc>
+                <a:tc>
+                  <a:txBody>
+                    <a:bodyPr/>
+                    <a:lstStyle/>
+                    <a:p>
+                      <a:pPr algn="ctr">
+                        <a:defRPr sz="1600">
+                          <a:solidFill>
+                            <a:srgbClr val="475569"/>
+                          </a:solidFill>
+                          <a:latin typeface="Calibri"/>
+                        </a:defRPr>
+                      </a:pPr>
+                      <a:r>
+                        <a:t>—</a:t>
+                      </a:r>
+                    </a:p>
+                  </a:txBody>
+                  <a:tcPr>
+                    <a:solidFill>
+                      <a:srgbClr val="FFFFFF"/>
+                    </a:solidFill>
+                  </a:tcPr>
+                </a:tc>
+                <a:tc>
+                  <a:txBody>
+                    <a:bodyPr/>
+                    <a:lstStyle/>
+                    <a:p>
+                      <a:pPr algn="ctr">
+                        <a:defRPr sz="1600">
+                          <a:solidFill>
+                            <a:srgbClr val="475569"/>
+                          </a:solidFill>
+                          <a:latin typeface="Calibri"/>
+                        </a:defRPr>
+                      </a:pPr>
+                      <a:r>
+                        <a:t>—</a:t>
+                      </a:r>
+                    </a:p>
+                  </a:txBody>
+                  <a:tcPr>
+                    <a:solidFill>
+                      <a:srgbClr val="FFFFFF"/>
+                    </a:solidFill>
+                  </a:tcPr>
+                </a:tc>
+                <a:tc>
+                  <a:txBody>
+                    <a:bodyPr/>
+                    <a:lstStyle/>
+                    <a:p>
+                      <a:pPr algn="ctr">
+                        <a:defRPr sz="1600" b="1">
+                          <a:solidFill>
+                            <a:srgbClr val="0F172A"/>
+                          </a:solidFill>
+                          <a:latin typeface="Calibri"/>
+                        </a:defRPr>
+                      </a:pPr>
+                      <a:r>
+                        <a:t>60 → 0</a:t>
+                      </a:r>
+                    </a:p>
+                  </a:txBody>
+                  <a:tcPr>
+                    <a:solidFill>
+                      <a:srgbClr val="F8FAFC"/>
+                    </a:solidFill>
+                  </a:tcPr>
+                </a:tc>
+                <a:extLst>
+                  <a:ext uri="{0D108BD9-81ED-4DB2-BD59-A6C34878D82A}">
+                    <a16:rowId xmlns:a16="http://schemas.microsoft.com/office/drawing/2014/main" val="10001"/>
+                  </a:ext>
+                </a:extLst>
+              </a:tr>
+              <a:tr h="822960">
+                <a:tc>
+                  <a:txBody>
+                    <a:bodyPr/>
+                    <a:lstStyle/>
+                    <a:p>
+                      <a:pPr algn="ctr">
+                        <a:defRPr sz="1600" b="1">
+                          <a:solidFill>
+                            <a:srgbClr val="0F172A"/>
+                          </a:solidFill>
+                          <a:latin typeface="Calibri"/>
+                        </a:defRPr>
+                      </a:pPr>
+                      <a:r>
+                        <a:t>A2</a:t>
+                      </a:r>
+                    </a:p>
+                  </a:txBody>
+                  <a:tcPr>
+                    <a:solidFill>
+                      <a:srgbClr val="FFFFFF"/>
+                    </a:solidFill>
+                  </a:tcPr>
+                </a:tc>
+                <a:tc>
+                  <a:txBody>
+                    <a:bodyPr/>
+                    <a:lstStyle/>
+                    <a:p>
+                      <a:pPr algn="ctr">
+                        <a:defRPr sz="1600">
+                          <a:solidFill>
+                            <a:srgbClr val="475569"/>
+                          </a:solidFill>
+                          <a:latin typeface="Calibri"/>
+                        </a:defRPr>
+                      </a:pPr>
+                      <a:r>
+                        <a:t>—</a:t>
+                      </a:r>
+                    </a:p>
+                  </a:txBody>
+                  <a:tcPr>
+                    <a:solidFill>
+                      <a:srgbClr val="FFFFFF"/>
+                    </a:solidFill>
+                  </a:tcPr>
+                </a:tc>
+                <a:tc>
+                  <a:txBody>
+                    <a:bodyPr/>
+                    <a:lstStyle/>
+                    <a:p>
+                      <a:pPr algn="ctr">
+                        <a:defRPr sz="1600" b="1">
+                          <a:solidFill>
+                            <a:srgbClr val="2563EB"/>
+                          </a:solidFill>
+                          <a:latin typeface="Calibri"/>
+                        </a:defRPr>
+                      </a:pPr>
+                      <a:r>
+                        <a:t>80</a:t>
+                      </a:r>
+                    </a:p>
+                  </a:txBody>
+                  <a:tcPr>
+                    <a:solidFill>
+                      <a:srgbClr val="FFFFFF"/>
+                    </a:solidFill>
+                  </a:tcPr>
+                </a:tc>
+                <a:tc>
+                  <a:txBody>
+                    <a:bodyPr/>
+                    <a:lstStyle/>
+                    <a:p>
+                      <a:pPr algn="ctr">
+                        <a:defRPr sz="1600">
+                          <a:solidFill>
+                            <a:srgbClr val="475569"/>
+                          </a:solidFill>
+                          <a:latin typeface="Calibri"/>
+                        </a:defRPr>
+                      </a:pPr>
+                      <a:r>
+                        <a:t>—</a:t>
+                      </a:r>
+                    </a:p>
+                  </a:txBody>
+                  <a:tcPr>
+                    <a:solidFill>
+                      <a:srgbClr val="FFFFFF"/>
+                    </a:solidFill>
+                  </a:tcPr>
+                </a:tc>
+                <a:tc>
+                  <a:txBody>
+                    <a:bodyPr/>
+                    <a:lstStyle/>
+                    <a:p>
+                      <a:pPr algn="ctr">
+                        <a:defRPr sz="1600" b="1">
+                          <a:solidFill>
+                            <a:srgbClr val="0F172A"/>
+                          </a:solidFill>
+                          <a:latin typeface="Calibri"/>
+                        </a:defRPr>
+                      </a:pPr>
+                      <a:r>
+                        <a:t>80 → 0</a:t>
+                      </a:r>
+                    </a:p>
+                  </a:txBody>
+                  <a:tcPr>
+                    <a:solidFill>
+                      <a:srgbClr val="F8FAFC"/>
+                    </a:solidFill>
+                  </a:tcPr>
+                </a:tc>
+                <a:extLst>
+                  <a:ext uri="{0D108BD9-81ED-4DB2-BD59-A6C34878D82A}">
+                    <a16:rowId xmlns:a16="http://schemas.microsoft.com/office/drawing/2014/main" val="10002"/>
+                  </a:ext>
+                </a:extLst>
+              </a:tr>
+              <a:tr h="822960">
+                <a:tc>
+                  <a:txBody>
+                    <a:bodyPr/>
+                    <a:lstStyle/>
+                    <a:p>
+                      <a:pPr algn="ctr">
+                        <a:defRPr sz="1600" b="1">
+                          <a:solidFill>
+                            <a:srgbClr val="0F172A"/>
+                          </a:solidFill>
+                          <a:latin typeface="Calibri"/>
+                        </a:defRPr>
+                      </a:pPr>
+                      <a:r>
+                        <a:t>A3</a:t>
+                      </a:r>
+                    </a:p>
+                  </a:txBody>
+                  <a:tcPr>
+                    <a:solidFill>
+                      <a:srgbClr val="FFFFFF"/>
+                    </a:solidFill>
+                  </a:tcPr>
+                </a:tc>
+                <a:tc>
+                  <a:txBody>
+                    <a:bodyPr/>
+                    <a:lstStyle/>
+                    <a:p>
+                      <a:pPr algn="ctr">
+                        <a:defRPr sz="1600" b="1">
+                          <a:solidFill>
+                            <a:srgbClr val="2563EB"/>
+                          </a:solidFill>
+                          <a:latin typeface="Calibri"/>
+                        </a:defRPr>
+                      </a:pPr>
+                      <a:r>
+                        <a:t>10</a:t>
+                      </a:r>
+                    </a:p>
+                  </a:txBody>
+                  <a:tcPr>
+                    <a:solidFill>
+                      <a:srgbClr val="FFFFFF"/>
+                    </a:solidFill>
+                  </a:tcPr>
+                </a:tc>
+                <a:tc>
+                  <a:txBody>
+                    <a:bodyPr/>
+                    <a:lstStyle/>
+                    <a:p>
+                      <a:pPr algn="ctr">
+                        <a:defRPr sz="1600" b="1">
+                          <a:solidFill>
+                            <a:srgbClr val="2563EB"/>
+                          </a:solidFill>
+                          <a:latin typeface="Calibri"/>
+                        </a:defRPr>
+                      </a:pPr>
+                      <a:r>
+                        <a:t>10</a:t>
+                      </a:r>
+                    </a:p>
+                  </a:txBody>
+                  <a:tcPr>
+                    <a:solidFill>
+                      <a:srgbClr val="FFFFFF"/>
+                    </a:solidFill>
+                  </a:tcPr>
+                </a:tc>
+                <a:tc>
+                  <a:txBody>
+                    <a:bodyPr/>
+                    <a:lstStyle/>
+                    <a:p>
+                      <a:pPr algn="ctr">
+                        <a:defRPr sz="1600" b="1">
+                          <a:solidFill>
+                            <a:srgbClr val="2563EB"/>
+                          </a:solidFill>
+                          <a:latin typeface="Calibri"/>
+                        </a:defRPr>
+                      </a:pPr>
+                      <a:r>
+                        <a:t>80</a:t>
+                      </a:r>
+                    </a:p>
+                  </a:txBody>
+                  <a:tcPr>
+                    <a:solidFill>
+                      <a:srgbClr val="FFFFFF"/>
+                    </a:solidFill>
+                  </a:tcPr>
+                </a:tc>
+                <a:tc>
+                  <a:txBody>
+                    <a:bodyPr/>
+                    <a:lstStyle/>
+                    <a:p>
+                      <a:pPr algn="ctr">
+                        <a:defRPr sz="1100" b="1">
+                          <a:solidFill>
+                            <a:srgbClr val="0F172A"/>
+                          </a:solidFill>
+                          <a:latin typeface="Calibri"/>
+                        </a:defRPr>
+                      </a:pPr>
+                      <a:r>
+                        <a:t>100 → 20 → 10 → 0</a:t>
+                      </a:r>
+                    </a:p>
+                  </a:txBody>
+                  <a:tcPr>
+                    <a:solidFill>
+                      <a:srgbClr val="F8FAFC"/>
+                    </a:solidFill>
+                  </a:tcPr>
+                </a:tc>
+                <a:extLst>
+                  <a:ext uri="{0D108BD9-81ED-4DB2-BD59-A6C34878D82A}">
+                    <a16:rowId xmlns:a16="http://schemas.microsoft.com/office/drawing/2014/main" val="10003"/>
+                  </a:ext>
+                </a:extLst>
+              </a:tr>
+              <a:tr h="822960">
+                <a:tc>
+                  <a:txBody>
+                    <a:bodyPr/>
+                    <a:lstStyle/>
+                    <a:p>
+                      <a:pPr algn="ctr">
+                        <a:defRPr sz="1600" b="1">
+                          <a:solidFill>
+                            <a:srgbClr val="0F172A"/>
+                          </a:solidFill>
+                          <a:latin typeface="Calibri"/>
+                        </a:defRPr>
+                      </a:pPr>
+                      <a:r>
+                        <a:t>Спрос B</a:t>
+                      </a:r>
+                    </a:p>
+                  </a:txBody>
+                  <a:tcPr>
+                    <a:solidFill>
+                      <a:srgbClr val="F8FAFC"/>
+                    </a:solidFill>
+                  </a:tcPr>
+                </a:tc>
+                <a:tc>
+                  <a:txBody>
+                    <a:bodyPr/>
+                    <a:lstStyle/>
+                    <a:p>
+                      <a:pPr algn="ctr">
+                        <a:defRPr sz="1300" b="1">
+                          <a:solidFill>
+                            <a:srgbClr val="0F172A"/>
+                          </a:solidFill>
+                          <a:latin typeface="Calibri"/>
+                        </a:defRPr>
+                      </a:pPr>
+                      <a:r>
+                        <a:t>70 → 10 → 0</a:t>
+                      </a:r>
+                    </a:p>
+                  </a:txBody>
+                  <a:tcPr>
+                    <a:solidFill>
+                      <a:srgbClr val="F8FAFC"/>
+                    </a:solidFill>
+                  </a:tcPr>
+                </a:tc>
+                <a:tc>
+                  <a:txBody>
+                    <a:bodyPr/>
+                    <a:lstStyle/>
+                    <a:p>
+                      <a:pPr algn="ctr">
+                        <a:defRPr sz="1300" b="1">
+                          <a:solidFill>
+                            <a:srgbClr val="0F172A"/>
+                          </a:solidFill>
+                          <a:latin typeface="Calibri"/>
+                        </a:defRPr>
+                      </a:pPr>
+                      <a:r>
+                        <a:t>90 → 10 → 0</a:t>
+                      </a:r>
+                    </a:p>
+                  </a:txBody>
+                  <a:tcPr>
+                    <a:solidFill>
+                      <a:srgbClr val="F8FAFC"/>
+                    </a:solidFill>
+                  </a:tcPr>
+                </a:tc>
+                <a:tc>
+                  <a:txBody>
+                    <a:bodyPr/>
+                    <a:lstStyle/>
+                    <a:p>
+                      <a:pPr algn="ctr">
+                        <a:defRPr sz="1600" b="1">
+                          <a:solidFill>
+                            <a:srgbClr val="0F172A"/>
+                          </a:solidFill>
+                          <a:latin typeface="Calibri"/>
+                        </a:defRPr>
+                      </a:pPr>
+                      <a:r>
+                        <a:t>80 → 0</a:t>
+                      </a:r>
+                    </a:p>
+                  </a:txBody>
+                  <a:tcPr>
+                    <a:solidFill>
+                      <a:srgbClr val="F8FAFC"/>
+                    </a:solidFill>
+                  </a:tcPr>
+                </a:tc>
+                <a:tc>
+                  <a:txBody>
+                    <a:bodyPr/>
+                    <a:lstStyle/>
+                    <a:p>
+                      <a:pPr algn="ctr">
+                        <a:defRPr sz="1600" b="1">
+                          <a:solidFill>
+                            <a:srgbClr val="0F172A"/>
+                          </a:solidFill>
+                          <a:latin typeface="Calibri"/>
+                        </a:defRPr>
+                      </a:pPr>
+                      <a:r>
+                        <a:t>240</a:t>
+                      </a:r>
+                    </a:p>
+                  </a:txBody>
+                  <a:tcPr>
+                    <a:solidFill>
+                      <a:srgbClr val="F8FAFC"/>
+                    </a:solidFill>
+                  </a:tcPr>
+                </a:tc>
+                <a:extLst>
+                  <a:ext uri="{0D108BD9-81ED-4DB2-BD59-A6C34878D82A}">
+                    <a16:rowId xmlns:a16="http://schemas.microsoft.com/office/drawing/2014/main" val="10004"/>
+                  </a:ext>
+                </a:extLst>
+              </a:tr>
+            </a:tbl>
+          </a:graphicData>
+        </a:graphic>
+      </p:graphicFrame>
+      <p:sp>
+        <p:nvSpPr>
+          <p:cNvPr id="6" name="TextBox 5"/>
           <p:cNvSpPr txBox="1"/>
           <p:nvPr/>
         </p:nvSpPr>
         <p:spPr>
           <a:xfrm>
-            <a:off x="548640" y="1645920"/>
-            <a:ext cx="11094415" cy="4572000"/>
+            <a:off x="6217920" y="1463040"/>
+            <a:ext cx="5303520" cy="4572000"/>
           </a:xfrm>
           <a:prstGeom prst="rect">
             <a:avLst/>
@@ -5786,7 +7655,7 @@
               <a:spcAft>
                 <a:spcPts val="1000"/>
               </a:spcAft>
-              <a:defRPr sz="2400" b="1">
+              <a:defRPr sz="2200" b="1">
                 <a:solidFill>
                   <a:srgbClr val="0F172A"/>
                 </a:solidFill>
@@ -5794,12 +7663,61 @@
               </a:defRPr>
             </a:pPr>
             <a:r>
-              <a:t>Осталась строка A3 (запасы 100):</a:t>
+              <a:t>Распределение для строки A3 (запас 100)</a:t>
             </a:r>
           </a:p>
           <a:p>
             <a:pPr>
-              <a:defRPr sz="2200">
+              <a:defRPr sz="1600" b="1"/>
+            </a:pPr>
+            <a:r>
+              <a:rPr sz="1600" b="1">
+                <a:solidFill>
+                  <a:srgbClr val="2563EB"/>
+                </a:solidFill>
+                <a:latin typeface="Arial"/>
+              </a:rPr>
+              <a:t>• Шаг 3. Клетка (A3, B3) с тарифом 3</a:t>
+            </a:r>
+          </a:p>
+          <a:p>
+            <a:pPr>
+              <a:defRPr sz="1600" b="0"/>
+            </a:pPr>
+            <a:r>
+              <a:rPr sz="1600" b="0">
+                <a:solidFill>
+                  <a:srgbClr val="0F172A"/>
+                </a:solidFill>
+                <a:latin typeface="Arial"/>
+              </a:rPr>
+              <a:t>  x</a:t>
+            </a:r>
+            <a:r>
+              <a:rPr sz="1100" b="0" baseline="-25000">
+                <a:solidFill>
+                  <a:srgbClr val="0F172A"/>
+                </a:solidFill>
+                <a:latin typeface="Arial"/>
+              </a:rPr>
+              <a:t>33</a:t>
+            </a:r>
+            <a:r>
+              <a:rPr sz="1600" b="0">
+                <a:solidFill>
+                  <a:srgbClr val="0F172A"/>
+                </a:solidFill>
+                <a:latin typeface="Arial"/>
+              </a:rPr>
+              <a:t> = min(100, 80) = 80</a:t>
+            </a:r>
+          </a:p>
+          <a:p>
+            <a:pPr>
+              <a:spcAft>
+                <a:spcPts val="600"/>
+              </a:spcAft>
+              <a:defRPr sz="1400">
                 <a:solidFill>
                   <a:srgbClr val="475569"/>
                 </a:solidFill>
@@ -5807,29 +7725,128 @@
               </a:defRPr>
             </a:pPr>
             <a:r>
-              <a:t>• Шаг 3. Клетка (A3, B3) с тарифом 3:</a:t>
-            </a:r>
-            <a:br/>
-            <a:r>
-              <a:t>  x_33 = min(100, 80) = 80. Потребитель B3 удовлетворен.</a:t>
-            </a:r>
-            <a:br/>
-            <a:br/>
-            <a:r>
-              <a:t>• Шаг 4. Клетка (A3, B1) с тарифом 8:</a:t>
-            </a:r>
-            <a:br/>
-            <a:r>
-              <a:t>  x_31 = min(20, 10) = 10. Потребитель B1 удовлетворен.</a:t>
-            </a:r>
-            <a:br/>
-            <a:br/>
-            <a:r>
-              <a:t>• Шаг 5. Клетка (A3, B2) с тарифом 11:</a:t>
-            </a:r>
-            <a:br/>
-            <a:r>
-              <a:t>  x_32 = min(10, 10) = 10. Все объемы распределены.</a:t>
+              <a:t>  Спрос B3 полностью удовлетворен. Запас A3 снижается до 20.</a:t>
+            </a:r>
+          </a:p>
+          <a:p>
+            <a:pPr>
+              <a:defRPr sz="1600" b="1"/>
+            </a:pPr>
+            <a:r>
+              <a:rPr sz="1600" b="1">
+                <a:solidFill>
+                  <a:srgbClr val="2563EB"/>
+                </a:solidFill>
+                <a:latin typeface="Arial"/>
+              </a:rPr>
+              <a:t>• Шаг 4. Клетка (A3, B1) с тарифом 8</a:t>
+            </a:r>
+          </a:p>
+          <a:p>
+            <a:pPr>
+              <a:defRPr sz="1600" b="0"/>
+            </a:pPr>
+            <a:r>
+              <a:rPr sz="1600" b="0">
+                <a:solidFill>
+                  <a:srgbClr val="0F172A"/>
+                </a:solidFill>
+                <a:latin typeface="Arial"/>
+              </a:rPr>
+              <a:t>  x</a:t>
+            </a:r>
+            <a:r>
+              <a:rPr sz="1100" b="0" baseline="-25000">
+                <a:solidFill>
+                  <a:srgbClr val="0F172A"/>
+                </a:solidFill>
+                <a:latin typeface="Arial"/>
+              </a:rPr>
+              <a:t>31</a:t>
+            </a:r>
+            <a:r>
+              <a:rPr sz="1600" b="0">
+                <a:solidFill>
+                  <a:srgbClr val="0F172A"/>
+                </a:solidFill>
+                <a:latin typeface="Arial"/>
+              </a:rPr>
+              <a:t> = min(20, 10) = 10</a:t>
+            </a:r>
+          </a:p>
+          <a:p>
+            <a:pPr>
+              <a:spcAft>
+                <a:spcPts val="600"/>
+              </a:spcAft>
+              <a:defRPr sz="1400">
+                <a:solidFill>
+                  <a:srgbClr val="475569"/>
+                </a:solidFill>
+                <a:latin typeface="Calibri"/>
+              </a:defRPr>
+            </a:pPr>
+            <a:r>
+              <a:t>  Спрос B1 полностью удовлетворен. Запас A3 снижается до 10.</a:t>
+            </a:r>
+          </a:p>
+          <a:p>
+            <a:pPr>
+              <a:defRPr sz="1600" b="1"/>
+            </a:pPr>
+            <a:r>
+              <a:rPr sz="1600" b="1">
+                <a:solidFill>
+                  <a:srgbClr val="2563EB"/>
+                </a:solidFill>
+                <a:latin typeface="Arial"/>
+              </a:rPr>
+              <a:t>• Шаг 5. Клетка (A3, B2) с тарифом 11</a:t>
+            </a:r>
+          </a:p>
+          <a:p>
+            <a:pPr>
+              <a:defRPr sz="1600" b="0"/>
+            </a:pPr>
+            <a:r>
+              <a:rPr sz="1600" b="0">
+                <a:solidFill>
+                  <a:srgbClr val="0F172A"/>
+                </a:solidFill>
+                <a:latin typeface="Arial"/>
+              </a:rPr>
+              <a:t>  x</a:t>
+            </a:r>
+            <a:r>
+              <a:rPr sz="1100" b="0" baseline="-25000">
+                <a:solidFill>
+                  <a:srgbClr val="0F172A"/>
+                </a:solidFill>
+                <a:latin typeface="Arial"/>
+              </a:rPr>
+              <a:t>32</a:t>
+            </a:r>
+            <a:r>
+              <a:rPr sz="1600" b="0">
+                <a:solidFill>
+                  <a:srgbClr val="0F172A"/>
+                </a:solidFill>
+                <a:latin typeface="Arial"/>
+              </a:rPr>
+              <a:t> = min(10, 10) = 10</a:t>
+            </a:r>
+          </a:p>
+          <a:p>
+            <a:pPr>
+              <a:defRPr sz="1400">
+                <a:solidFill>
+                  <a:srgbClr val="475569"/>
+                </a:solidFill>
+                <a:latin typeface="Calibri"/>
+              </a:defRPr>
+            </a:pPr>
+            <a:r>
+              <a:t>  Запас поставщика A3 и спрос потребителя B2 полностью исчерпаны.</a:t>
             </a:r>
           </a:p>
         </p:txBody>
@@ -5843,7 +7860,7 @@
 </file>
 
 <file path=ppt/slides/slide9.xml><?xml version="1.0" encoding="utf-8"?>
-<p:sld xmlns:a="http://schemas.openxmlformats.org/drawingml/2006/main" xmlns:p="http://schemas.openxmlformats.org/presentationml/2006/main" xmlns:r="http://schemas.openxmlformats.org/officeDocument/2006/relationships">
+<p:sld xmlns:a="http://schemas.openxmlformats.org/drawingml/2006/main" xmlns:r="http://schemas.openxmlformats.org/officeDocument/2006/relationships" xmlns:p="http://schemas.openxmlformats.org/presentationml/2006/main">
   <p:cSld>
     <p:bg>
       <p:bgPr>
@@ -5859,7 +7876,14 @@
         <p:cNvGrpSpPr/>
         <p:nvPr/>
       </p:nvGrpSpPr>
-      <p:grpSpPr/>
+      <p:grpSpPr>
+        <a:xfrm>
+          <a:off x="0" y="0"/>
+          <a:ext cx="0" cy="0"/>
+          <a:chOff x="0" y="0"/>
+          <a:chExt cx="0" cy="0"/>
+        </a:xfrm>
+      </p:grpSpPr>
       <p:sp>
         <p:nvSpPr>
           <p:cNvPr id="2" name="TextBox 1"/>
@@ -5972,6 +7996,7 @@
           <a:lstStyle/>
           <a:p>
             <a:pPr algn="ctr"/>
+            <a:endParaRPr/>
           </a:p>
         </p:txBody>
       </p:sp>
@@ -5994,11 +8019,41 @@
                 <a:tableStyleId>{5C22544A-7EE6-4342-B048-85BDC9FD1C3A}</a:tableStyleId>
               </a:tblPr>
               <a:tblGrid>
-                <a:gridCol w="1097280"/>
-                <a:gridCol w="1097280"/>
-                <a:gridCol w="1097280"/>
-                <a:gridCol w="1097280"/>
-                <a:gridCol w="1097280"/>
+                <a:gridCol w="1097280">
+                  <a:extLst>
+                    <a:ext uri="{9D8B030D-6E8A-4147-A177-3AD203B41FA5}">
+                      <a16:colId xmlns:a16="http://schemas.microsoft.com/office/drawing/2014/main" val="20000"/>
+                    </a:ext>
+                  </a:extLst>
+                </a:gridCol>
+                <a:gridCol w="1097280">
+                  <a:extLst>
+                    <a:ext uri="{9D8B030D-6E8A-4147-A177-3AD203B41FA5}">
+                      <a16:colId xmlns:a16="http://schemas.microsoft.com/office/drawing/2014/main" val="20001"/>
+                    </a:ext>
+                  </a:extLst>
+                </a:gridCol>
+                <a:gridCol w="1097280">
+                  <a:extLst>
+                    <a:ext uri="{9D8B030D-6E8A-4147-A177-3AD203B41FA5}">
+                      <a16:colId xmlns:a16="http://schemas.microsoft.com/office/drawing/2014/main" val="20002"/>
+                    </a:ext>
+                  </a:extLst>
+                </a:gridCol>
+                <a:gridCol w="1097280">
+                  <a:extLst>
+                    <a:ext uri="{9D8B030D-6E8A-4147-A177-3AD203B41FA5}">
+                      <a16:colId xmlns:a16="http://schemas.microsoft.com/office/drawing/2014/main" val="20003"/>
+                    </a:ext>
+                  </a:extLst>
+                </a:gridCol>
+                <a:gridCol w="1097280">
+                  <a:extLst>
+                    <a:ext uri="{9D8B030D-6E8A-4147-A177-3AD203B41FA5}">
+                      <a16:colId xmlns:a16="http://schemas.microsoft.com/office/drawing/2014/main" val="20004"/>
+                    </a:ext>
+                  </a:extLst>
+                </a:gridCol>
               </a:tblGrid>
               <a:tr h="822960">
                 <a:tc>
@@ -6007,7 +8062,7 @@
                     <a:lstStyle/>
                     <a:p>
                       <a:pPr algn="ctr">
-                        <a:defRPr sz="1600" b="1">
+                        <a:defRPr sz="1400" b="1">
                           <a:solidFill>
                             <a:srgbClr val="0F172A"/>
                           </a:solidFill>
@@ -6015,7 +8070,7 @@
                         </a:defRPr>
                       </a:pPr>
                       <a:r>
-                        <a:t>Пост.</a:t>
+                        <a:t>Пост. \ Потр.</a:t>
                       </a:r>
                     </a:p>
                   </a:txBody>
@@ -6031,7 +8086,7 @@
                     <a:lstStyle/>
                     <a:p>
                       <a:pPr algn="ctr">
-                        <a:defRPr sz="1600" b="1">
+                        <a:defRPr sz="1400" b="1">
                           <a:solidFill>
                             <a:srgbClr val="0F172A"/>
                           </a:solidFill>
@@ -6055,7 +8110,7 @@
                     <a:lstStyle/>
                     <a:p>
                       <a:pPr algn="ctr">
-                        <a:defRPr sz="1600" b="1">
+                        <a:defRPr sz="1400" b="1">
                           <a:solidFill>
                             <a:srgbClr val="0F172A"/>
                           </a:solidFill>
@@ -6079,7 +8134,7 @@
                     <a:lstStyle/>
                     <a:p>
                       <a:pPr algn="ctr">
-                        <a:defRPr sz="1600" b="1">
+                        <a:defRPr sz="1400" b="1">
                           <a:solidFill>
                             <a:srgbClr val="0F172A"/>
                           </a:solidFill>
@@ -6103,7 +8158,7 @@
                     <a:lstStyle/>
                     <a:p>
                       <a:pPr algn="ctr">
-                        <a:defRPr sz="1600" b="1">
+                        <a:defRPr sz="1400" b="1">
                           <a:solidFill>
                             <a:srgbClr val="0F172A"/>
                           </a:solidFill>
@@ -6111,7 +8166,7 @@
                         </a:defRPr>
                       </a:pPr>
                       <a:r>
-                        <a:t>Запас</a:t>
+                        <a:t>Запасы A</a:t>
                       </a:r>
                     </a:p>
                   </a:txBody>
@@ -6121,6 +8176,11 @@
                     </a:solidFill>
                   </a:tcPr>
                 </a:tc>
+                <a:extLst>
+                  <a:ext uri="{0D108BD9-81ED-4DB2-BD59-A6C34878D82A}">
+                    <a16:rowId xmlns:a16="http://schemas.microsoft.com/office/drawing/2014/main" val="10000"/>
+                  </a:ext>
+                </a:extLst>
               </a:tr>
               <a:tr h="822960">
                 <a:tc>
@@ -6129,7 +8189,7 @@
                     <a:lstStyle/>
                     <a:p>
                       <a:pPr algn="ctr">
-                        <a:defRPr sz="1800">
+                        <a:defRPr sz="1600" b="1">
                           <a:solidFill>
                             <a:srgbClr val="0F172A"/>
                           </a:solidFill>
@@ -6153,7 +8213,7 @@
                     <a:lstStyle/>
                     <a:p>
                       <a:pPr algn="ctr">
-                        <a:defRPr sz="1800" b="1">
+                        <a:defRPr sz="1600" b="1">
                           <a:solidFill>
                             <a:srgbClr val="2563EB"/>
                           </a:solidFill>
@@ -6177,7 +8237,55 @@
                     <a:lstStyle/>
                     <a:p>
                       <a:pPr algn="ctr">
-                        <a:defRPr sz="1800">
+                        <a:defRPr sz="1600">
+                          <a:solidFill>
+                            <a:srgbClr val="475569"/>
+                          </a:solidFill>
+                          <a:latin typeface="Calibri"/>
+                        </a:defRPr>
+                      </a:pPr>
+                      <a:r>
+                        <a:t>—</a:t>
+                      </a:r>
+                    </a:p>
+                  </a:txBody>
+                  <a:tcPr>
+                    <a:solidFill>
+                      <a:srgbClr val="FFFFFF"/>
+                    </a:solidFill>
+                  </a:tcPr>
+                </a:tc>
+                <a:tc>
+                  <a:txBody>
+                    <a:bodyPr/>
+                    <a:lstStyle/>
+                    <a:p>
+                      <a:pPr algn="ctr">
+                        <a:defRPr sz="1600">
+                          <a:solidFill>
+                            <a:srgbClr val="475569"/>
+                          </a:solidFill>
+                          <a:latin typeface="Calibri"/>
+                        </a:defRPr>
+                      </a:pPr>
+                      <a:r>
+                        <a:t>—</a:t>
+                      </a:r>
+                    </a:p>
+                  </a:txBody>
+                  <a:tcPr>
+                    <a:solidFill>
+                      <a:srgbClr val="FFFFFF"/>
+                    </a:solidFill>
+                  </a:tcPr>
+                </a:tc>
+                <a:tc>
+                  <a:txBody>
+                    <a:bodyPr/>
+                    <a:lstStyle/>
+                    <a:p>
+                      <a:pPr algn="ctr">
+                        <a:defRPr sz="1600" b="1">
                           <a:solidFill>
                             <a:srgbClr val="0F172A"/>
                           </a:solidFill>
@@ -6185,55 +8293,7 @@
                         </a:defRPr>
                       </a:pPr>
                       <a:r>
-                        <a:t>—</a:t>
-                      </a:r>
-                    </a:p>
-                  </a:txBody>
-                  <a:tcPr>
-                    <a:solidFill>
-                      <a:srgbClr val="FFFFFF"/>
-                    </a:solidFill>
-                  </a:tcPr>
-                </a:tc>
-                <a:tc>
-                  <a:txBody>
-                    <a:bodyPr/>
-                    <a:lstStyle/>
-                    <a:p>
-                      <a:pPr algn="ctr">
-                        <a:defRPr sz="1800">
-                          <a:solidFill>
-                            <a:srgbClr val="0F172A"/>
-                          </a:solidFill>
-                          <a:latin typeface="Calibri"/>
-                        </a:defRPr>
-                      </a:pPr>
-                      <a:r>
-                        <a:t>—</a:t>
-                      </a:r>
-                    </a:p>
-                  </a:txBody>
-                  <a:tcPr>
-                    <a:solidFill>
-                      <a:srgbClr val="FFFFFF"/>
-                    </a:solidFill>
-                  </a:tcPr>
-                </a:tc>
-                <a:tc>
-                  <a:txBody>
-                    <a:bodyPr/>
-                    <a:lstStyle/>
-                    <a:p>
-                      <a:pPr algn="ctr">
-                        <a:defRPr sz="1800">
-                          <a:solidFill>
-                            <a:srgbClr val="0F172A"/>
-                          </a:solidFill>
-                          <a:latin typeface="Calibri"/>
-                        </a:defRPr>
-                      </a:pPr>
-                      <a:r>
-                        <a:t>60</a:t>
+                        <a:t>60 → 0</a:t>
                       </a:r>
                     </a:p>
                   </a:txBody>
@@ -6243,6 +8303,11 @@
                     </a:solidFill>
                   </a:tcPr>
                 </a:tc>
+                <a:extLst>
+                  <a:ext uri="{0D108BD9-81ED-4DB2-BD59-A6C34878D82A}">
+                    <a16:rowId xmlns:a16="http://schemas.microsoft.com/office/drawing/2014/main" val="10001"/>
+                  </a:ext>
+                </a:extLst>
               </a:tr>
               <a:tr h="822960">
                 <a:tc>
@@ -6251,7 +8316,7 @@
                     <a:lstStyle/>
                     <a:p>
                       <a:pPr algn="ctr">
-                        <a:defRPr sz="1800">
+                        <a:defRPr sz="1600" b="1">
                           <a:solidFill>
                             <a:srgbClr val="0F172A"/>
                           </a:solidFill>
@@ -6275,7 +8340,79 @@
                     <a:lstStyle/>
                     <a:p>
                       <a:pPr algn="ctr">
-                        <a:defRPr sz="1800">
+                        <a:defRPr sz="1600">
+                          <a:solidFill>
+                            <a:srgbClr val="475569"/>
+                          </a:solidFill>
+                          <a:latin typeface="Calibri"/>
+                        </a:defRPr>
+                      </a:pPr>
+                      <a:r>
+                        <a:t>—</a:t>
+                      </a:r>
+                    </a:p>
+                  </a:txBody>
+                  <a:tcPr>
+                    <a:solidFill>
+                      <a:srgbClr val="FFFFFF"/>
+                    </a:solidFill>
+                  </a:tcPr>
+                </a:tc>
+                <a:tc>
+                  <a:txBody>
+                    <a:bodyPr/>
+                    <a:lstStyle/>
+                    <a:p>
+                      <a:pPr algn="ctr">
+                        <a:defRPr sz="1600" b="1">
+                          <a:solidFill>
+                            <a:srgbClr val="2563EB"/>
+                          </a:solidFill>
+                          <a:latin typeface="Calibri"/>
+                        </a:defRPr>
+                      </a:pPr>
+                      <a:r>
+                        <a:t>80</a:t>
+                      </a:r>
+                    </a:p>
+                  </a:txBody>
+                  <a:tcPr>
+                    <a:solidFill>
+                      <a:srgbClr val="FFFFFF"/>
+                    </a:solidFill>
+                  </a:tcPr>
+                </a:tc>
+                <a:tc>
+                  <a:txBody>
+                    <a:bodyPr/>
+                    <a:lstStyle/>
+                    <a:p>
+                      <a:pPr algn="ctr">
+                        <a:defRPr sz="1600">
+                          <a:solidFill>
+                            <a:srgbClr val="475569"/>
+                          </a:solidFill>
+                          <a:latin typeface="Calibri"/>
+                        </a:defRPr>
+                      </a:pPr>
+                      <a:r>
+                        <a:t>—</a:t>
+                      </a:r>
+                    </a:p>
+                  </a:txBody>
+                  <a:tcPr>
+                    <a:solidFill>
+                      <a:srgbClr val="FFFFFF"/>
+                    </a:solidFill>
+                  </a:tcPr>
+                </a:tc>
+                <a:tc>
+                  <a:txBody>
+                    <a:bodyPr/>
+                    <a:lstStyle/>
+                    <a:p>
+                      <a:pPr algn="ctr">
+                        <a:defRPr sz="1600" b="1">
                           <a:solidFill>
                             <a:srgbClr val="0F172A"/>
                           </a:solidFill>
@@ -6283,79 +8420,7 @@
                         </a:defRPr>
                       </a:pPr>
                       <a:r>
-                        <a:t>—</a:t>
-                      </a:r>
-                    </a:p>
-                  </a:txBody>
-                  <a:tcPr>
-                    <a:solidFill>
-                      <a:srgbClr val="FFFFFF"/>
-                    </a:solidFill>
-                  </a:tcPr>
-                </a:tc>
-                <a:tc>
-                  <a:txBody>
-                    <a:bodyPr/>
-                    <a:lstStyle/>
-                    <a:p>
-                      <a:pPr algn="ctr">
-                        <a:defRPr sz="1800" b="1">
-                          <a:solidFill>
-                            <a:srgbClr val="2563EB"/>
-                          </a:solidFill>
-                          <a:latin typeface="Calibri"/>
-                        </a:defRPr>
-                      </a:pPr>
-                      <a:r>
-                        <a:t>80</a:t>
-                      </a:r>
-                    </a:p>
-                  </a:txBody>
-                  <a:tcPr>
-                    <a:solidFill>
-                      <a:srgbClr val="FFFFFF"/>
-                    </a:solidFill>
-                  </a:tcPr>
-                </a:tc>
-                <a:tc>
-                  <a:txBody>
-                    <a:bodyPr/>
-                    <a:lstStyle/>
-                    <a:p>
-                      <a:pPr algn="ctr">
-                        <a:defRPr sz="1800">
-                          <a:solidFill>
-                            <a:srgbClr val="0F172A"/>
-                          </a:solidFill>
-                          <a:latin typeface="Calibri"/>
-                        </a:defRPr>
-                      </a:pPr>
-                      <a:r>
-                        <a:t>—</a:t>
-                      </a:r>
-                    </a:p>
-                  </a:txBody>
-                  <a:tcPr>
-                    <a:solidFill>
-                      <a:srgbClr val="FFFFFF"/>
-                    </a:solidFill>
-                  </a:tcPr>
-                </a:tc>
-                <a:tc>
-                  <a:txBody>
-                    <a:bodyPr/>
-                    <a:lstStyle/>
-                    <a:p>
-                      <a:pPr algn="ctr">
-                        <a:defRPr sz="1800">
-                          <a:solidFill>
-                            <a:srgbClr val="0F172A"/>
-                          </a:solidFill>
-                          <a:latin typeface="Calibri"/>
-                        </a:defRPr>
-                      </a:pPr>
-                      <a:r>
-                        <a:t>80</a:t>
+                        <a:t>80 → 0</a:t>
                       </a:r>
                     </a:p>
                   </a:txBody>
@@ -6365,6 +8430,11 @@
                     </a:solidFill>
                   </a:tcPr>
                 </a:tc>
+                <a:extLst>
+                  <a:ext uri="{0D108BD9-81ED-4DB2-BD59-A6C34878D82A}">
+                    <a16:rowId xmlns:a16="http://schemas.microsoft.com/office/drawing/2014/main" val="10002"/>
+                  </a:ext>
+                </a:extLst>
               </a:tr>
               <a:tr h="822960">
                 <a:tc>
@@ -6373,7 +8443,7 @@
                     <a:lstStyle/>
                     <a:p>
                       <a:pPr algn="ctr">
-                        <a:defRPr sz="1800">
+                        <a:defRPr sz="1600" b="1">
                           <a:solidFill>
                             <a:srgbClr val="0F172A"/>
                           </a:solidFill>
@@ -6397,7 +8467,7 @@
                     <a:lstStyle/>
                     <a:p>
                       <a:pPr algn="ctr">
-                        <a:defRPr sz="1800" b="1">
+                        <a:defRPr sz="1600" b="1">
                           <a:solidFill>
                             <a:srgbClr val="2563EB"/>
                           </a:solidFill>
@@ -6421,7 +8491,7 @@
                     <a:lstStyle/>
                     <a:p>
                       <a:pPr algn="ctr">
-                        <a:defRPr sz="1800" b="1">
+                        <a:defRPr sz="1600" b="1">
                           <a:solidFill>
                             <a:srgbClr val="2563EB"/>
                           </a:solidFill>
@@ -6445,7 +8515,7 @@
                     <a:lstStyle/>
                     <a:p>
                       <a:pPr algn="ctr">
-                        <a:defRPr sz="1800" b="1">
+                        <a:defRPr sz="1600" b="1">
                           <a:solidFill>
                             <a:srgbClr val="2563EB"/>
                           </a:solidFill>
@@ -6469,7 +8539,7 @@
                     <a:lstStyle/>
                     <a:p>
                       <a:pPr algn="ctr">
-                        <a:defRPr sz="1800">
+                        <a:defRPr sz="1600" b="1">
                           <a:solidFill>
                             <a:srgbClr val="0F172A"/>
                           </a:solidFill>
@@ -6477,7 +8547,7 @@
                         </a:defRPr>
                       </a:pPr>
                       <a:r>
-                        <a:t>100</a:t>
+                        <a:t>100 → 0</a:t>
                       </a:r>
                     </a:p>
                   </a:txBody>
@@ -6487,6 +8557,11 @@
                     </a:solidFill>
                   </a:tcPr>
                 </a:tc>
+                <a:extLst>
+                  <a:ext uri="{0D108BD9-81ED-4DB2-BD59-A6C34878D82A}">
+                    <a16:rowId xmlns:a16="http://schemas.microsoft.com/office/drawing/2014/main" val="10003"/>
+                  </a:ext>
+                </a:extLst>
               </a:tr>
               <a:tr h="822960">
                 <a:tc>
@@ -6495,7 +8570,7 @@
                     <a:lstStyle/>
                     <a:p>
                       <a:pPr algn="ctr">
-                        <a:defRPr sz="1800">
+                        <a:defRPr sz="1600" b="1">
                           <a:solidFill>
                             <a:srgbClr val="0F172A"/>
                           </a:solidFill>
@@ -6503,7 +8578,7 @@
                         </a:defRPr>
                       </a:pPr>
                       <a:r>
-                        <a:t>Спрос</a:t>
+                        <a:t>Спрос B</a:t>
                       </a:r>
                     </a:p>
                   </a:txBody>
@@ -6519,7 +8594,7 @@
                     <a:lstStyle/>
                     <a:p>
                       <a:pPr algn="ctr">
-                        <a:defRPr sz="1800">
+                        <a:defRPr sz="1600" b="1">
                           <a:solidFill>
                             <a:srgbClr val="0F172A"/>
                           </a:solidFill>
@@ -6527,7 +8602,7 @@
                         </a:defRPr>
                       </a:pPr>
                       <a:r>
-                        <a:t>70</a:t>
+                        <a:t>70 → 0</a:t>
                       </a:r>
                     </a:p>
                   </a:txBody>
@@ -6543,7 +8618,7 @@
                     <a:lstStyle/>
                     <a:p>
                       <a:pPr algn="ctr">
-                        <a:defRPr sz="1800">
+                        <a:defRPr sz="1600" b="1">
                           <a:solidFill>
                             <a:srgbClr val="0F172A"/>
                           </a:solidFill>
@@ -6551,7 +8626,7 @@
                         </a:defRPr>
                       </a:pPr>
                       <a:r>
-                        <a:t>90</a:t>
+                        <a:t>90 → 0</a:t>
                       </a:r>
                     </a:p>
                   </a:txBody>
@@ -6567,7 +8642,7 @@
                     <a:lstStyle/>
                     <a:p>
                       <a:pPr algn="ctr">
-                        <a:defRPr sz="1800">
+                        <a:defRPr sz="1600" b="1">
                           <a:solidFill>
                             <a:srgbClr val="0F172A"/>
                           </a:solidFill>
@@ -6575,7 +8650,7 @@
                         </a:defRPr>
                       </a:pPr>
                       <a:r>
-                        <a:t>80</a:t>
+                        <a:t>80 → 0</a:t>
                       </a:r>
                     </a:p>
                   </a:txBody>
@@ -6591,7 +8666,7 @@
                     <a:lstStyle/>
                     <a:p>
                       <a:pPr algn="ctr">
-                        <a:defRPr sz="1800">
+                        <a:defRPr sz="1600" b="1">
                           <a:solidFill>
                             <a:srgbClr val="0F172A"/>
                           </a:solidFill>
@@ -6609,6 +8684,11 @@
                     </a:solidFill>
                   </a:tcPr>
                 </a:tc>
+                <a:extLst>
+                  <a:ext uri="{0D108BD9-81ED-4DB2-BD59-A6C34878D82A}">
+                    <a16:rowId xmlns:a16="http://schemas.microsoft.com/office/drawing/2014/main" val="10004"/>
+                  </a:ext>
+                </a:extLst>
               </a:tr>
             </a:tbl>
           </a:graphicData>
@@ -6637,6 +8717,9 @@
           <a:lstStyle/>
           <a:p>
             <a:pPr>
+              <a:spcAft>
+                <a:spcPts val="1000"/>
+              </a:spcAft>
               <a:defRPr sz="2400" b="1">
                 <a:solidFill>
                   <a:srgbClr val="0F172A"/>
@@ -6649,35 +8732,132 @@
             </a:r>
           </a:p>
           <a:p>
+            <a:pPr>
+              <a:defRPr sz="2000" b="1"/>
+            </a:pPr>
+            <a:r>
+              <a:rPr sz="2000" b="1">
+                <a:solidFill>
+                  <a:srgbClr val="2563EB"/>
+                </a:solidFill>
+                <a:latin typeface="Arial"/>
+              </a:rPr>
+              <a:t>Z = 60•2 + 80•1 + 80•3 + 10•8 + 10•11</a:t>
+            </a:r>
+          </a:p>
+          <a:p>
+            <a:pPr>
+              <a:spcAft>
+                <a:spcPts val="1400"/>
+              </a:spcAft>
+              <a:defRPr sz="2400" b="1"/>
+            </a:pPr>
+            <a:r>
+              <a:rPr sz="2400" b="1">
+                <a:solidFill>
+                  <a:srgbClr val="2563EB"/>
+                </a:solidFill>
+                <a:latin typeface="Arial"/>
+              </a:rPr>
+              <a:t>Z = 630 ед.</a:t>
+            </a:r>
+          </a:p>
+          <a:p>
+            <a:pPr>
+              <a:spcAft>
+                <a:spcPts val="400"/>
+              </a:spcAft>
+              <a:defRPr sz="2000" b="1">
+                <a:solidFill>
+                  <a:srgbClr val="0F172A"/>
+                </a:solidFill>
+                <a:latin typeface="Arial"/>
+              </a:defRPr>
+            </a:pPr>
+            <a:r>
+              <a:t>Сравнение начальных планов:</a:t>
+            </a:r>
             <a:br/>
+            <a:endParaRPr/>
+          </a:p>
+          <a:p>
             <a:pPr>
-              <a:defRPr sz="2200">
+              <a:defRPr sz="1800" b="0"/>
+            </a:pPr>
+            <a:r>
+              <a:rPr sz="1800" b="0">
                 <a:solidFill>
                   <a:srgbClr val="475569"/>
+                </a:solidFill>
+                <a:latin typeface="Arial"/>
+              </a:rPr>
+              <a:t>• Метод Мин. Элемента: Z</a:t>
+            </a:r>
+            <a:r>
+              <a:rPr sz="1200" b="0" baseline="-25000">
+                <a:solidFill>
+                  <a:srgbClr val="475569"/>
+                </a:solidFill>
+                <a:latin typeface="Arial"/>
+              </a:rPr>
+              <a:t>мин</a:t>
+            </a:r>
+            <a:r>
+              <a:rPr sz="1800" b="0">
+                <a:solidFill>
+                  <a:srgbClr val="475569"/>
+                </a:solidFill>
+                <a:latin typeface="Arial"/>
+              </a:rPr>
+              <a:t> = 630 ед.</a:t>
+            </a:r>
+          </a:p>
+          <a:p>
+            <a:pPr>
+              <a:spcAft>
+                <a:spcPts val="800"/>
+              </a:spcAft>
+              <a:defRPr sz="1800" b="0"/>
+            </a:pPr>
+            <a:r>
+              <a:rPr sz="1800" b="0">
+                <a:solidFill>
+                  <a:srgbClr val="475569"/>
+                </a:solidFill>
+                <a:latin typeface="Arial"/>
+              </a:rPr>
+              <a:t>• Метод Сев.-Зап. угла: Z</a:t>
+            </a:r>
+            <a:r>
+              <a:rPr sz="1200" b="0" baseline="-25000">
+                <a:solidFill>
+                  <a:srgbClr val="475569"/>
+                </a:solidFill>
+                <a:latin typeface="Arial"/>
+              </a:rPr>
+              <a:t>сз</a:t>
+            </a:r>
+            <a:r>
+              <a:rPr sz="1800" b="0">
+                <a:solidFill>
+                  <a:srgbClr val="475569"/>
+                </a:solidFill>
+                <a:latin typeface="Arial"/>
+              </a:rPr>
+              <a:t> = 770 ед.</a:t>
+            </a:r>
+          </a:p>
+          <a:p>
+            <a:pPr>
+              <a:defRPr sz="1800">
+                <a:solidFill>
+                  <a:srgbClr val="0F172A"/>
                 </a:solidFill>
                 <a:latin typeface="Calibri"/>
               </a:defRPr>
             </a:pPr>
             <a:r>
-              <a:t>Z = 60•2 + 80•1 + 80•3 + 10•8 + 10•11 = 630 ед.</a:t>
-            </a:r>
-            <a:br/>
-            <a:br/>
-            <a:r>
-              <a:t>Сравнение:</a:t>
-            </a:r>
-            <a:br/>
-            <a:r>
-              <a:t>• Метод Минимального Элемента: Z = 630 ед.</a:t>
-            </a:r>
-            <a:br/>
-            <a:r>
-              <a:t>• Метод Северо-Западного угла: Z = 770 ед.</a:t>
-            </a:r>
-            <a:br/>
-            <a:br/>
-            <a:r>
-              <a:t>Экономия составляет более 18%!</a:t>
+              <a:t>Экономия на первом шаге составляет более 18%!</a:t>
             </a:r>
           </a:p>
         </p:txBody>

</xml_diff>